<commit_message>
sql scripts v2 und presentation
</commit_message>
<xml_diff>
--- a/presentation/MemoryOptimizedTables_SQLDatenbanken.pptx
+++ b/presentation/MemoryOptimizedTables_SQLDatenbanken.pptx
@@ -23090,6 +23090,18 @@
           </a:p>
           <a:p>
             <a:r>
+              <a:rPr lang="de-DE" dirty="0"/>
+              <a:t>Speicherung page-basiert </a:t>
+            </a:r>
+          </a:p>
+          <a:p>
+            <a:r>
+              <a:rPr lang="de-DE" dirty="0"/>
+              <a:t>Indexseiten werden im Transaktionslog protokolliert</a:t>
+            </a:r>
+          </a:p>
+          <a:p>
+            <a:r>
               <a:rPr lang="de-DE" dirty="0" err="1"/>
               <a:t>Locking</a:t>
             </a:r>
@@ -23229,6 +23241,83 @@
           <a:p>
             <a:r>
               <a:rPr lang="en-GB" dirty="0" err="1"/>
+              <a:t>Persistierung</a:t>
+            </a:r>
+            <a:r>
+              <a:rPr lang="en-GB" dirty="0"/>
+              <a:t> von </a:t>
+            </a:r>
+            <a:r>
+              <a:rPr lang="en-GB" dirty="0" err="1"/>
+              <a:t>Indexdefinitionen</a:t>
+            </a:r>
+            <a:r>
+              <a:rPr lang="en-GB" dirty="0"/>
+              <a:t>. Aufbau </a:t>
+            </a:r>
+            <a:r>
+              <a:rPr lang="en-GB" dirty="0" err="1"/>
+              <a:t>Indexe</a:t>
+            </a:r>
+            <a:r>
+              <a:rPr lang="en-GB" dirty="0"/>
+              <a:t> </a:t>
+            </a:r>
+            <a:r>
+              <a:rPr lang="en-GB" dirty="0" err="1"/>
+              <a:t>bei</a:t>
+            </a:r>
+            <a:r>
+              <a:rPr lang="en-GB" dirty="0"/>
+              <a:t> </a:t>
+            </a:r>
+            <a:r>
+              <a:rPr lang="en-GB" dirty="0" err="1"/>
+              <a:t>Datenbankstart</a:t>
+            </a:r>
+            <a:r>
+              <a:rPr lang="en-GB" dirty="0"/>
+              <a:t>.</a:t>
+            </a:r>
+          </a:p>
+          <a:p>
+            <a:pPr lvl="1"/>
+            <a:r>
+              <a:rPr lang="en-GB" dirty="0" err="1"/>
+              <a:t>V.a.</a:t>
+            </a:r>
+            <a:r>
+              <a:rPr lang="en-GB" dirty="0"/>
+              <a:t> Hash </a:t>
+            </a:r>
+            <a:r>
+              <a:rPr lang="en-GB" dirty="0" err="1"/>
+              <a:t>Indizes</a:t>
+            </a:r>
+            <a:r>
+              <a:rPr lang="en-GB" dirty="0"/>
+              <a:t> / </a:t>
+            </a:r>
+            <a:r>
+              <a:rPr lang="en-GB" dirty="0" err="1"/>
+              <a:t>Bw_Tree-Basierte</a:t>
+            </a:r>
+            <a:r>
+              <a:rPr lang="en-GB" dirty="0"/>
+              <a:t> Range </a:t>
+            </a:r>
+            <a:r>
+              <a:rPr lang="en-GB" dirty="0" err="1"/>
+              <a:t>Indizes</a:t>
+            </a:r>
+            <a:r>
+              <a:rPr lang="en-GB" dirty="0"/>
+              <a:t> </a:t>
+            </a:r>
+          </a:p>
+          <a:p>
+            <a:r>
+              <a:rPr lang="en-GB" dirty="0" err="1"/>
               <a:t>Spezielle</a:t>
             </a:r>
             <a:r>
@@ -23250,42 +23339,6 @@
             <a:endParaRPr lang="en-GB" dirty="0"/>
           </a:p>
           <a:p>
-            <a:endParaRPr lang="en-CH" dirty="0"/>
-          </a:p>
-        </p:txBody>
-      </p:sp>
-      <p:sp>
-        <p:nvSpPr>
-          <p:cNvPr id="6" name="TextBox 5">
-            <a:extLst>
-              <a:ext uri="{FF2B5EF4-FFF2-40B4-BE49-F238E27FC236}">
-                <a16:creationId xmlns:a16="http://schemas.microsoft.com/office/drawing/2014/main" id="{A59E5C55-55EE-1140-50F3-A1EF57CAF644}"/>
-              </a:ext>
-            </a:extLst>
-          </p:cNvPr>
-          <p:cNvSpPr txBox="1"/>
-          <p:nvPr/>
-        </p:nvSpPr>
-        <p:spPr>
-          <a:xfrm>
-            <a:off x="3478138" y="5563312"/>
-            <a:ext cx="4828374" cy="923330"/>
-          </a:xfrm>
-          <a:prstGeom prst="rect">
-            <a:avLst/>
-          </a:prstGeom>
-          <a:noFill/>
-        </p:spPr>
-        <p:txBody>
-          <a:bodyPr wrap="square" rtlCol="0">
-            <a:spAutoFit/>
-          </a:bodyPr>
-          <a:lstStyle/>
-          <a:p>
-            <a:r>
-              <a:rPr lang="de-DE" dirty="0"/>
-              <a:t>Technisch ist es eine andere Storage Engine mit eigener Dateistruktur und eigenen Einschränkungen</a:t>
-            </a:r>
             <a:endParaRPr lang="en-CH" dirty="0"/>
           </a:p>
         </p:txBody>
@@ -24463,13 +24516,13 @@
             </a:r>
           </a:p>
           <a:p>
-            <a:pPr marL="0" indent="0">
-              <a:buFont typeface="Arial" panose="020B0604020202020204" pitchFamily="34" charset="0"/>
-              <a:buNone/>
+            <a:pPr>
+              <a:buFontTx/>
+              <a:buChar char="-"/>
             </a:pPr>
             <a:r>
               <a:rPr lang="de-CH" dirty="0"/>
-              <a:t>- Recovery </a:t>
+              <a:t>Recovery </a:t>
             </a:r>
             <a:r>
               <a:rPr lang="de-CH" dirty="0" err="1"/>
@@ -24492,8 +24545,261 @@
               <a:t>critical</a:t>
             </a:r>
             <a:r>
-              <a:rPr lang="de-CH"/>
+              <a:rPr lang="de-CH" dirty="0"/>
+              <a:t> (</a:t>
+            </a:r>
+            <a:r>
+              <a:rPr lang="de-CH" dirty="0" err="1"/>
+              <a:t>cold</a:t>
+            </a:r>
+            <a:r>
+              <a:rPr lang="de-CH" dirty="0"/>
               <a:t> </a:t>
+            </a:r>
+            <a:r>
+              <a:rPr lang="de-CH" dirty="0" err="1"/>
+              <a:t>starts</a:t>
+            </a:r>
+            <a:r>
+              <a:rPr lang="de-CH" dirty="0"/>
+              <a:t> </a:t>
+            </a:r>
+            <a:r>
+              <a:rPr lang="de-CH" dirty="0" err="1"/>
+              <a:t>with</a:t>
+            </a:r>
+            <a:r>
+              <a:rPr lang="de-CH" dirty="0"/>
+              <a:t> </a:t>
+            </a:r>
+            <a:r>
+              <a:rPr lang="de-CH" dirty="0" err="1"/>
+              <a:t>empty</a:t>
+            </a:r>
+            <a:r>
+              <a:rPr lang="de-CH" dirty="0"/>
+              <a:t> </a:t>
+            </a:r>
+            <a:r>
+              <a:rPr lang="de-CH" dirty="0" err="1"/>
+              <a:t>caches</a:t>
+            </a:r>
+            <a:r>
+              <a:rPr lang="de-CH" dirty="0"/>
+              <a:t>) </a:t>
+            </a:r>
+            <a:r>
+              <a:rPr lang="de-CH" dirty="0" err="1"/>
+              <a:t>load</a:t>
+            </a:r>
+            <a:r>
+              <a:rPr lang="de-CH" dirty="0"/>
+              <a:t> </a:t>
+            </a:r>
+            <a:r>
+              <a:rPr lang="de-CH" dirty="0" err="1"/>
+              <a:t>data</a:t>
+            </a:r>
+            <a:r>
+              <a:rPr lang="de-CH" dirty="0"/>
+              <a:t> in </a:t>
+            </a:r>
+            <a:r>
+              <a:rPr lang="de-CH" dirty="0" err="1"/>
+              <a:t>batches</a:t>
+            </a:r>
+            <a:endParaRPr lang="de-CH" dirty="0"/>
+          </a:p>
+          <a:p>
+            <a:pPr>
+              <a:buFontTx/>
+              <a:buChar char="-"/>
+            </a:pPr>
+            <a:endParaRPr lang="de-CH" dirty="0"/>
+          </a:p>
+          <a:p>
+            <a:pPr>
+              <a:buFontTx/>
+              <a:buChar char="-"/>
+            </a:pPr>
+            <a:r>
+              <a:rPr lang="de-CH" dirty="0"/>
+              <a:t>Memory </a:t>
+            </a:r>
+            <a:r>
+              <a:rPr lang="de-CH" dirty="0" err="1"/>
+              <a:t>fragmentation</a:t>
+            </a:r>
+            <a:r>
+              <a:rPr lang="de-CH" dirty="0"/>
+              <a:t> (</a:t>
+            </a:r>
+            <a:r>
+              <a:rPr lang="de-CH" dirty="0" err="1"/>
+              <a:t>memory</a:t>
+            </a:r>
+            <a:r>
+              <a:rPr lang="de-CH" dirty="0"/>
+              <a:t> </a:t>
+            </a:r>
+            <a:r>
+              <a:rPr lang="de-CH" dirty="0" err="1"/>
+              <a:t>fragmentation</a:t>
+            </a:r>
+            <a:r>
+              <a:rPr lang="de-CH" dirty="0"/>
+              <a:t> </a:t>
+            </a:r>
+            <a:r>
+              <a:rPr lang="de-CH" dirty="0" err="1"/>
+              <a:t>can</a:t>
+            </a:r>
+            <a:r>
+              <a:rPr lang="de-CH" dirty="0"/>
+              <a:t> </a:t>
+            </a:r>
+            <a:r>
+              <a:rPr lang="de-CH" dirty="0" err="1"/>
+              <a:t>degrade</a:t>
+            </a:r>
+            <a:r>
+              <a:rPr lang="de-CH" dirty="0"/>
+              <a:t> </a:t>
+            </a:r>
+            <a:r>
+              <a:rPr lang="de-CH" dirty="0" err="1"/>
+              <a:t>performance</a:t>
+            </a:r>
+            <a:r>
+              <a:rPr lang="de-CH" dirty="0"/>
+              <a:t> </a:t>
+            </a:r>
+            <a:r>
+              <a:rPr lang="de-CH" dirty="0" err="1"/>
+              <a:t>over</a:t>
+            </a:r>
+            <a:r>
+              <a:rPr lang="de-CH" dirty="0"/>
+              <a:t> time) -&gt; plan </a:t>
+            </a:r>
+            <a:r>
+              <a:rPr lang="de-CH" dirty="0" err="1"/>
+              <a:t>regular</a:t>
+            </a:r>
+            <a:r>
+              <a:rPr lang="de-CH" dirty="0"/>
+              <a:t> </a:t>
+            </a:r>
+            <a:r>
+              <a:rPr lang="de-CH" dirty="0" err="1"/>
+              <a:t>restarts</a:t>
+            </a:r>
+            <a:endParaRPr lang="de-CH" dirty="0"/>
+          </a:p>
+          <a:p>
+            <a:pPr>
+              <a:buFontTx/>
+              <a:buChar char="-"/>
+            </a:pPr>
+            <a:r>
+              <a:rPr lang="de-CH" dirty="0"/>
+              <a:t>Data </a:t>
+            </a:r>
+            <a:r>
+              <a:rPr lang="de-CH" dirty="0" err="1"/>
+              <a:t>structure</a:t>
+            </a:r>
+            <a:r>
+              <a:rPr lang="de-CH" dirty="0"/>
+              <a:t> </a:t>
+            </a:r>
+            <a:r>
+              <a:rPr lang="de-CH" dirty="0" err="1"/>
+              <a:t>selection</a:t>
+            </a:r>
+            <a:r>
+              <a:rPr lang="de-CH" dirty="0"/>
+              <a:t> </a:t>
+            </a:r>
+            <a:r>
+              <a:rPr lang="de-CH" dirty="0" err="1"/>
+              <a:t>matters</a:t>
+            </a:r>
+            <a:r>
+              <a:rPr lang="de-CH" dirty="0"/>
+              <a:t> </a:t>
+            </a:r>
+            <a:r>
+              <a:rPr lang="de-CH" dirty="0" err="1"/>
+              <a:t>enormously</a:t>
+            </a:r>
+            <a:r>
+              <a:rPr lang="de-CH" dirty="0"/>
+              <a:t>. Switch </a:t>
+            </a:r>
+            <a:r>
+              <a:rPr lang="de-CH" dirty="0" err="1"/>
+              <a:t>from</a:t>
+            </a:r>
+            <a:r>
+              <a:rPr lang="de-CH" dirty="0"/>
+              <a:t> </a:t>
+            </a:r>
+            <a:r>
+              <a:rPr lang="de-CH" dirty="0" err="1"/>
+              <a:t>hash</a:t>
+            </a:r>
+            <a:r>
+              <a:rPr lang="de-CH" dirty="0"/>
+              <a:t> </a:t>
+            </a:r>
+            <a:r>
+              <a:rPr lang="de-CH" dirty="0" err="1"/>
+              <a:t>tables</a:t>
+            </a:r>
+            <a:r>
+              <a:rPr lang="de-CH" dirty="0"/>
+              <a:t> </a:t>
+            </a:r>
+            <a:r>
+              <a:rPr lang="de-CH" dirty="0" err="1"/>
+              <a:t>to</a:t>
+            </a:r>
+            <a:r>
+              <a:rPr lang="de-CH" dirty="0"/>
+              <a:t> </a:t>
+            </a:r>
+            <a:r>
+              <a:rPr lang="de-CH" dirty="0" err="1"/>
+              <a:t>specialized</a:t>
+            </a:r>
+            <a:r>
+              <a:rPr lang="de-CH" dirty="0"/>
+              <a:t> </a:t>
+            </a:r>
+            <a:r>
+              <a:rPr lang="de-CH" dirty="0" err="1"/>
+              <a:t>radic</a:t>
+            </a:r>
+            <a:r>
+              <a:rPr lang="de-CH" dirty="0"/>
+              <a:t> </a:t>
+            </a:r>
+            <a:r>
+              <a:rPr lang="de-CH" dirty="0" err="1"/>
+              <a:t>trees</a:t>
+            </a:r>
+            <a:r>
+              <a:rPr lang="de-CH" dirty="0"/>
+              <a:t> </a:t>
+            </a:r>
+            <a:r>
+              <a:rPr lang="de-CH" dirty="0" err="1"/>
+              <a:t>improvement</a:t>
+            </a:r>
+            <a:r>
+              <a:rPr lang="de-CH" dirty="0"/>
+              <a:t>? </a:t>
             </a:r>
             <a:endParaRPr lang="en-CH" dirty="0"/>
           </a:p>

</xml_diff>

<commit_message>
sql scripts v3 und presentation
</commit_message>
<xml_diff>
--- a/presentation/MemoryOptimizedTables_SQLDatenbanken.pptx
+++ b/presentation/MemoryOptimizedTables_SQLDatenbanken.pptx
@@ -13,6 +13,7 @@
     <p:sldId id="262" r:id="rId7"/>
     <p:sldId id="261" r:id="rId8"/>
     <p:sldId id="263" r:id="rId9"/>
+    <p:sldId id="265" r:id="rId10"/>
   </p:sldIdLst>
   <p:sldSz cx="12192000" cy="6858000"/>
   <p:notesSz cx="6858000" cy="9144000"/>
@@ -22273,7 +22274,7 @@
             <p:ph sz="quarter" idx="13"/>
             <p:extLst>
               <p:ext uri="{D42A27DB-BD31-4B8C-83A1-F6EECF244321}">
-                <p14:modId xmlns:p14="http://schemas.microsoft.com/office/powerpoint/2010/main" val="3452986559"/>
+                <p14:modId xmlns:p14="http://schemas.microsoft.com/office/powerpoint/2010/main" val="396645844"/>
               </p:ext>
               <p:ext uri="{E7BDC344-281C-4309-B0C6-D0EE65EED2A8}">
                 <p202:designPr xmlns:p202="http://schemas.microsoft.com/office/powerpoint/2020/02/main">
@@ -22367,7 +22368,7 @@
                             <a:schemeClr val="tx1"/>
                           </a:solidFill>
                         </a:rPr>
-                        <a:t>Disk vs in Memory Table</a:t>
+                        <a:t>Disk vs in MOT Table</a:t>
                       </a:r>
                     </a:p>
                   </a:txBody>
@@ -22574,7 +22575,7 @@
                             <a:schemeClr val="tx1"/>
                           </a:solidFill>
                         </a:rPr>
-                        <a:t> in Memory Table</a:t>
+                        <a:t> Memory Optimized Table</a:t>
                       </a:r>
                     </a:p>
                   </a:txBody>
@@ -22697,7 +22698,7 @@
                             <a:schemeClr val="tx1"/>
                           </a:solidFill>
                         </a:rPr>
-                        <a:t> in Memory Table</a:t>
+                        <a:t> Memory Optimized Table</a:t>
                       </a:r>
                     </a:p>
                   </a:txBody>
@@ -23127,6 +23128,28 @@
             </a:r>
           </a:p>
           <a:p>
+            <a:r>
+              <a:rPr lang="de-DE" dirty="0"/>
+              <a:t>Page Fragmentierung (bedarf </a:t>
+            </a:r>
+            <a:r>
+              <a:rPr lang="de-DE" dirty="0" err="1"/>
+              <a:t>Rebuild</a:t>
+            </a:r>
+            <a:r>
+              <a:rPr lang="de-DE" dirty="0"/>
+              <a:t>/</a:t>
+            </a:r>
+            <a:r>
+              <a:rPr lang="de-DE" dirty="0" err="1"/>
+              <a:t>Reorganize</a:t>
+            </a:r>
+            <a:r>
+              <a:rPr lang="de-DE" dirty="0"/>
+              <a:t> von Indizes)</a:t>
+            </a:r>
+          </a:p>
+          <a:p>
             <a:endParaRPr lang="en-CH" dirty="0"/>
           </a:p>
         </p:txBody>
@@ -23149,7 +23172,9 @@
         </p:nvSpPr>
         <p:spPr/>
         <p:txBody>
-          <a:bodyPr/>
+          <a:bodyPr>
+            <a:normAutofit fontScale="92500" lnSpcReduction="10000"/>
+          </a:bodyPr>
           <a:lstStyle/>
           <a:p>
             <a:pPr marL="0" indent="0">
@@ -23205,6 +23230,106 @@
           </a:p>
           <a:p>
             <a:r>
+              <a:rPr lang="en-GB" dirty="0" err="1"/>
+              <a:t>Spezielle</a:t>
+            </a:r>
+            <a:r>
+              <a:rPr lang="en-GB" dirty="0"/>
+              <a:t> Filegroup </a:t>
+            </a:r>
+            <a:r>
+              <a:rPr lang="en-GB" dirty="0" err="1"/>
+              <a:t>MEMORY_OPTIMIZED_DATA</a:t>
+            </a:r>
+            <a:r>
+              <a:rPr lang="en-GB" dirty="0"/>
+              <a:t>, Durability-</a:t>
+            </a:r>
+            <a:r>
+              <a:rPr lang="en-GB" dirty="0" err="1"/>
+              <a:t>Optionen</a:t>
+            </a:r>
+            <a:endParaRPr lang="en-GB" dirty="0"/>
+          </a:p>
+          <a:p>
+            <a:r>
+              <a:rPr lang="en-GB" dirty="0" err="1"/>
+              <a:t>Persistierung</a:t>
+            </a:r>
+            <a:r>
+              <a:rPr lang="en-GB" dirty="0"/>
+              <a:t> von </a:t>
+            </a:r>
+            <a:r>
+              <a:rPr lang="en-GB" dirty="0" err="1"/>
+              <a:t>Indexdefinitionen</a:t>
+            </a:r>
+            <a:r>
+              <a:rPr lang="en-GB" dirty="0"/>
+              <a:t>. Aufbau </a:t>
+            </a:r>
+            <a:r>
+              <a:rPr lang="en-GB" dirty="0" err="1"/>
+              <a:t>Indexe</a:t>
+            </a:r>
+            <a:r>
+              <a:rPr lang="en-GB" dirty="0"/>
+              <a:t> </a:t>
+            </a:r>
+            <a:r>
+              <a:rPr lang="en-GB" dirty="0" err="1"/>
+              <a:t>bei</a:t>
+            </a:r>
+            <a:r>
+              <a:rPr lang="en-GB" dirty="0"/>
+              <a:t> </a:t>
+            </a:r>
+            <a:r>
+              <a:rPr lang="en-GB" dirty="0" err="1"/>
+              <a:t>Datenbankstart</a:t>
+            </a:r>
+            <a:r>
+              <a:rPr lang="en-GB" dirty="0"/>
+              <a:t>.</a:t>
+            </a:r>
+          </a:p>
+          <a:p>
+            <a:pPr lvl="1"/>
+            <a:r>
+              <a:rPr lang="en-GB" dirty="0" err="1"/>
+              <a:t>V.a.</a:t>
+            </a:r>
+            <a:r>
+              <a:rPr lang="en-GB" dirty="0"/>
+              <a:t> Hash </a:t>
+            </a:r>
+            <a:r>
+              <a:rPr lang="en-GB" dirty="0" err="1"/>
+              <a:t>Indizes</a:t>
+            </a:r>
+            <a:r>
+              <a:rPr lang="en-GB" dirty="0"/>
+              <a:t> / </a:t>
+            </a:r>
+            <a:r>
+              <a:rPr lang="en-GB" dirty="0" err="1"/>
+              <a:t>Bw_Tree-Basierte</a:t>
+            </a:r>
+            <a:r>
+              <a:rPr lang="en-GB" dirty="0"/>
+              <a:t> Range </a:t>
+            </a:r>
+            <a:r>
+              <a:rPr lang="en-GB" dirty="0" err="1"/>
+              <a:t>Indizes</a:t>
+            </a:r>
+            <a:r>
+              <a:rPr lang="en-GB" dirty="0"/>
+              <a:t> </a:t>
+            </a:r>
+          </a:p>
+          <a:p>
+            <a:r>
               <a:rPr lang="en-GB" dirty="0"/>
               <a:t>Lock-</a:t>
             </a:r>
@@ -23222,42 +23347,22 @@
             </a:r>
             <a:r>
               <a:rPr lang="en-GB" dirty="0"/>
-              <a:t> MVCC-</a:t>
+              <a:t> multi-version Concurrency-Modell MVCC-</a:t>
             </a:r>
             <a:r>
               <a:rPr lang="en-GB" dirty="0" err="1"/>
               <a:t>Struktur</a:t>
             </a:r>
+            <a:endParaRPr lang="en-GB" dirty="0"/>
+          </a:p>
+          <a:p>
             <a:r>
               <a:rPr lang="en-GB" dirty="0"/>
-              <a:t>, Hash-/Range-</a:t>
+              <a:t>Alte </a:t>
             </a:r>
             <a:r>
               <a:rPr lang="en-GB" dirty="0" err="1"/>
-              <a:t>Indizes</a:t>
-            </a:r>
-            <a:endParaRPr lang="en-GB" dirty="0"/>
-          </a:p>
-          <a:p>
-            <a:r>
-              <a:rPr lang="en-GB" dirty="0" err="1"/>
-              <a:t>Persistierung</a:t>
-            </a:r>
-            <a:r>
-              <a:rPr lang="en-GB" dirty="0"/>
-              <a:t> von </a:t>
-            </a:r>
-            <a:r>
-              <a:rPr lang="en-GB" dirty="0" err="1"/>
-              <a:t>Indexdefinitionen</a:t>
-            </a:r>
-            <a:r>
-              <a:rPr lang="en-GB" dirty="0"/>
-              <a:t>. Aufbau </a:t>
-            </a:r>
-            <a:r>
-              <a:rPr lang="en-GB" dirty="0" err="1"/>
-              <a:t>Indexe</a:t>
+              <a:t>Zeilenversionen</a:t>
             </a:r>
             <a:r>
               <a:rPr lang="en-GB" dirty="0"/>
@@ -23265,7 +23370,7 @@
             </a:r>
             <a:r>
               <a:rPr lang="en-GB" dirty="0" err="1"/>
-              <a:t>bei</a:t>
+              <a:t>müssen</a:t>
             </a:r>
             <a:r>
               <a:rPr lang="en-GB" dirty="0"/>
@@ -23273,69 +23378,27 @@
             </a:r>
             <a:r>
               <a:rPr lang="en-GB" dirty="0" err="1"/>
-              <a:t>Datenbankstart</a:t>
+              <a:t>mit</a:t>
             </a:r>
             <a:r>
               <a:rPr lang="en-GB" dirty="0"/>
-              <a:t>.</a:t>
-            </a:r>
-          </a:p>
-          <a:p>
-            <a:pPr lvl="1"/>
+              <a:t> Merge thread </a:t>
+            </a:r>
             <a:r>
               <a:rPr lang="en-GB" dirty="0" err="1"/>
-              <a:t>V.a.</a:t>
-            </a:r>
-            <a:r>
-              <a:rPr lang="en-GB" dirty="0"/>
-              <a:t> Hash </a:t>
-            </a:r>
-            <a:r>
-              <a:rPr lang="en-GB" dirty="0" err="1"/>
-              <a:t>Indizes</a:t>
-            </a:r>
-            <a:r>
-              <a:rPr lang="en-GB" dirty="0"/>
-              <a:t> / </a:t>
-            </a:r>
-            <a:r>
-              <a:rPr lang="en-GB" dirty="0" err="1"/>
-              <a:t>Bw_Tree-Basierte</a:t>
-            </a:r>
-            <a:r>
-              <a:rPr lang="en-GB" dirty="0"/>
-              <a:t> Range </a:t>
-            </a:r>
-            <a:r>
-              <a:rPr lang="en-GB" dirty="0" err="1"/>
-              <a:t>Indizes</a:t>
+              <a:t>zusammengeführt</a:t>
             </a:r>
             <a:r>
               <a:rPr lang="en-GB" dirty="0"/>
               <a:t> </a:t>
             </a:r>
-          </a:p>
-          <a:p>
             <a:r>
               <a:rPr lang="en-GB" dirty="0" err="1"/>
-              <a:t>Spezielle</a:t>
-            </a:r>
-            <a:r>
-              <a:rPr lang="en-GB" dirty="0"/>
-              <a:t> Filegroup </a:t>
-            </a:r>
-            <a:r>
-              <a:rPr lang="en-GB" dirty="0" err="1"/>
-              <a:t>MEMORY_OPTIMIZED_DATA</a:t>
-            </a:r>
-            <a:r>
-              <a:rPr lang="en-GB" dirty="0"/>
-              <a:t>, Durability-</a:t>
-            </a:r>
-            <a:r>
-              <a:rPr lang="en-GB" dirty="0" err="1"/>
-              <a:t>Optionen</a:t>
-            </a:r>
+              <a:t>werden</a:t>
+            </a:r>
+            <a:endParaRPr lang="en-GB" dirty="0"/>
+          </a:p>
+          <a:p>
             <a:endParaRPr lang="en-GB" dirty="0"/>
           </a:p>
           <a:p>
@@ -24308,7 +24371,15 @@
           <a:p>
             <a:r>
               <a:rPr lang="de-CH" dirty="0"/>
-              <a:t>Vor- und Nachteile «in Memory» Table</a:t>
+              <a:t>Vor- und Nachteile  Memory </a:t>
+            </a:r>
+            <a:r>
+              <a:rPr lang="de-CH" dirty="0" err="1"/>
+              <a:t>Optimized</a:t>
+            </a:r>
+            <a:r>
+              <a:rPr lang="de-CH" dirty="0"/>
+              <a:t> Table</a:t>
             </a:r>
             <a:endParaRPr lang="en-CH" dirty="0"/>
           </a:p>
@@ -24615,13 +24686,6 @@
               <a:buFontTx/>
               <a:buChar char="-"/>
             </a:pPr>
-            <a:endParaRPr lang="de-CH" dirty="0"/>
-          </a:p>
-          <a:p>
-            <a:pPr>
-              <a:buFontTx/>
-              <a:buChar char="-"/>
-            </a:pPr>
             <a:r>
               <a:rPr lang="de-CH" dirty="0"/>
               <a:t>Memory </a:t>
@@ -24869,6 +24933,37 @@
               <a:rPr lang="de-CH" dirty="0"/>
               <a:t>Vorteile «in Memory» Table</a:t>
             </a:r>
+          </a:p>
+          <a:p>
+            <a:pPr marL="0" indent="0">
+              <a:buNone/>
+            </a:pPr>
+            <a:endParaRPr lang="de-CH" dirty="0"/>
+          </a:p>
+          <a:p>
+            <a:pPr marL="0" indent="0">
+              <a:buNone/>
+            </a:pPr>
+            <a:r>
+              <a:rPr lang="de-CH" dirty="0"/>
+              <a:t>Sehr gute </a:t>
+            </a:r>
+            <a:r>
+              <a:rPr lang="de-CH" dirty="0" err="1"/>
+              <a:t>performance</a:t>
+            </a:r>
+            <a:r>
+              <a:rPr lang="de-CH" dirty="0"/>
+              <a:t> bei passendem OLTP Workloads (z.B. vielen kurzen Transaktionen, Hot </a:t>
+            </a:r>
+            <a:r>
+              <a:rPr lang="de-CH" dirty="0" err="1"/>
+              <a:t>Tables</a:t>
+            </a:r>
+            <a:r>
+              <a:rPr lang="de-CH" dirty="0"/>
+              <a:t>, Sessions- oder Queue Tabellen)</a:t>
+            </a:r>
             <a:endParaRPr lang="en-CH" dirty="0"/>
           </a:p>
         </p:txBody>
@@ -24931,7 +25026,23 @@
           <a:p>
             <a:r>
               <a:rPr lang="de-CH" dirty="0"/>
-              <a:t>Beispiel Nachteil «in Memory» Table gegenüber «in </a:t>
+              <a:t>Beispiel Nachteil Memory </a:t>
+            </a:r>
+            <a:r>
+              <a:rPr lang="de-CH" dirty="0" err="1"/>
+              <a:t>Optimized</a:t>
+            </a:r>
+            <a:r>
+              <a:rPr lang="de-CH" dirty="0"/>
+              <a:t> </a:t>
+            </a:r>
+            <a:r>
+              <a:rPr lang="de-CH" dirty="0" err="1"/>
+              <a:t>vs</a:t>
+            </a:r>
+            <a:r>
+              <a:rPr lang="de-CH" dirty="0"/>
+              <a:t>  «in </a:t>
             </a:r>
             <a:r>
               <a:rPr lang="de-CH" dirty="0" err="1"/>
@@ -25145,7 +25256,33 @@
               <a:rPr lang="de-CH" dirty="0"/>
               <a:t>Nachteile «in Memory» Table</a:t>
             </a:r>
-            <a:endParaRPr lang="en-CH" dirty="0"/>
+          </a:p>
+          <a:p>
+            <a:pPr marL="0" indent="0">
+              <a:buFont typeface="Arial" panose="020B0604020202020204" pitchFamily="34" charset="0"/>
+              <a:buNone/>
+            </a:pPr>
+            <a:endParaRPr lang="de-CH" dirty="0"/>
+          </a:p>
+          <a:p>
+            <a:pPr marL="0" indent="0">
+              <a:buFont typeface="Arial" panose="020B0604020202020204" pitchFamily="34" charset="0"/>
+              <a:buNone/>
+            </a:pPr>
+            <a:r>
+              <a:rPr lang="de-CH" dirty="0"/>
+              <a:t>Über RAM begrenzt</a:t>
+            </a:r>
+          </a:p>
+          <a:p>
+            <a:pPr marL="0" indent="0">
+              <a:buFont typeface="Arial" panose="020B0604020202020204" pitchFamily="34" charset="0"/>
+              <a:buNone/>
+            </a:pPr>
+            <a:r>
+              <a:rPr lang="de-CH" dirty="0"/>
+              <a:t>Datentypen Constraints</a:t>
+            </a:r>
           </a:p>
         </p:txBody>
       </p:sp>
@@ -25153,6 +25290,1953 @@
     <p:extLst>
       <p:ext uri="{BB962C8B-B14F-4D97-AF65-F5344CB8AC3E}">
         <p14:creationId xmlns:p14="http://schemas.microsoft.com/office/powerpoint/2010/main" val="335068550"/>
+      </p:ext>
+    </p:extLst>
+  </p:cSld>
+  <p:clrMapOvr>
+    <a:masterClrMapping/>
+  </p:clrMapOvr>
+</p:sld>
+</file>
+
+<file path=ppt/slides/slide9.xml><?xml version="1.0" encoding="utf-8"?>
+<p:sld xmlns:a="http://schemas.openxmlformats.org/drawingml/2006/main" xmlns:r="http://schemas.openxmlformats.org/officeDocument/2006/relationships" xmlns:p="http://schemas.openxmlformats.org/presentationml/2006/main">
+  <p:cSld>
+    <p:spTree>
+      <p:nvGrpSpPr>
+        <p:cNvPr id="1" name=""/>
+        <p:cNvGrpSpPr/>
+        <p:nvPr/>
+      </p:nvGrpSpPr>
+      <p:grpSpPr>
+        <a:xfrm>
+          <a:off x="0" y="0"/>
+          <a:ext cx="0" cy="0"/>
+          <a:chOff x="0" y="0"/>
+          <a:chExt cx="0" cy="0"/>
+        </a:xfrm>
+      </p:grpSpPr>
+      <p:sp>
+        <p:nvSpPr>
+          <p:cNvPr id="2" name="Title 1">
+            <a:extLst>
+              <a:ext uri="{FF2B5EF4-FFF2-40B4-BE49-F238E27FC236}">
+                <a16:creationId xmlns:a16="http://schemas.microsoft.com/office/drawing/2014/main" id="{3E460989-2BA5-C934-C371-59ABD89AF6F2}"/>
+              </a:ext>
+            </a:extLst>
+          </p:cNvPr>
+          <p:cNvSpPr>
+            <a:spLocks noGrp="1"/>
+          </p:cNvSpPr>
+          <p:nvPr>
+            <p:ph type="title"/>
+          </p:nvPr>
+        </p:nvSpPr>
+        <p:spPr/>
+        <p:txBody>
+          <a:bodyPr/>
+          <a:lstStyle/>
+          <a:p>
+            <a:r>
+              <a:rPr lang="de-CH" dirty="0"/>
+              <a:t>Anhang</a:t>
+            </a:r>
+            <a:endParaRPr lang="en-CH" dirty="0"/>
+          </a:p>
+        </p:txBody>
+      </p:sp>
+      <p:sp>
+        <p:nvSpPr>
+          <p:cNvPr id="3" name="Content Placeholder 2">
+            <a:extLst>
+              <a:ext uri="{FF2B5EF4-FFF2-40B4-BE49-F238E27FC236}">
+                <a16:creationId xmlns:a16="http://schemas.microsoft.com/office/drawing/2014/main" id="{21373E59-A7C9-BFB4-08BB-DC39FC4EDCD5}"/>
+              </a:ext>
+            </a:extLst>
+          </p:cNvPr>
+          <p:cNvSpPr>
+            <a:spLocks noGrp="1"/>
+          </p:cNvSpPr>
+          <p:nvPr>
+            <p:ph sz="quarter" idx="13"/>
+          </p:nvPr>
+        </p:nvSpPr>
+        <p:spPr>
+          <a:xfrm>
+            <a:off x="7332292" y="1103861"/>
+            <a:ext cx="4060072" cy="1797350"/>
+          </a:xfrm>
+        </p:spPr>
+        <p:txBody>
+          <a:bodyPr/>
+          <a:lstStyle/>
+          <a:p>
+            <a:r>
+              <a:rPr lang="de-DE" dirty="0"/>
+              <a:t>In einer Transaktion können beide Typen kombiniert werden, meist mit READ </a:t>
+            </a:r>
+            <a:r>
+              <a:rPr lang="de-DE" dirty="0" err="1"/>
+              <a:t>COMMITTED</a:t>
+            </a:r>
+            <a:r>
+              <a:rPr lang="de-DE" dirty="0"/>
+              <a:t> für Disk‑Tabellen und </a:t>
+            </a:r>
+            <a:r>
+              <a:rPr lang="de-DE" dirty="0" err="1"/>
+              <a:t>SERIALIZABLE</a:t>
+            </a:r>
+            <a:r>
+              <a:rPr lang="de-DE" dirty="0"/>
+              <a:t>‑ähnlicher Isolation für in </a:t>
+            </a:r>
+            <a:r>
+              <a:rPr lang="de-DE" dirty="0" err="1"/>
+              <a:t>memory</a:t>
+            </a:r>
+            <a:r>
+              <a:rPr lang="de-DE" dirty="0"/>
+              <a:t> Tabellen</a:t>
+            </a:r>
+            <a:endParaRPr lang="en-CH" dirty="0"/>
+          </a:p>
+        </p:txBody>
+      </p:sp>
+      <p:graphicFrame>
+        <p:nvGraphicFramePr>
+          <p:cNvPr id="4" name="Table 3">
+            <a:extLst>
+              <a:ext uri="{FF2B5EF4-FFF2-40B4-BE49-F238E27FC236}">
+                <a16:creationId xmlns:a16="http://schemas.microsoft.com/office/drawing/2014/main" id="{E732A028-81D2-DDC3-10A8-350E9A730978}"/>
+              </a:ext>
+            </a:extLst>
+          </p:cNvPr>
+          <p:cNvGraphicFramePr>
+            <a:graphicFrameLocks noGrp="1"/>
+          </p:cNvGraphicFramePr>
+          <p:nvPr>
+            <p:extLst>
+              <p:ext uri="{D42A27DB-BD31-4B8C-83A1-F6EECF244321}">
+                <p14:modId xmlns:p14="http://schemas.microsoft.com/office/powerpoint/2010/main" val="4085196458"/>
+              </p:ext>
+            </p:extLst>
+          </p:nvPr>
+        </p:nvGraphicFramePr>
+        <p:xfrm>
+          <a:off x="612648" y="1554520"/>
+          <a:ext cx="5770512" cy="4581104"/>
+        </p:xfrm>
+        <a:graphic>
+          <a:graphicData uri="http://schemas.openxmlformats.org/drawingml/2006/table">
+            <a:tbl>
+              <a:tblPr/>
+              <a:tblGrid>
+                <a:gridCol w="1923504">
+                  <a:extLst>
+                    <a:ext uri="{9D8B030D-6E8A-4147-A177-3AD203B41FA5}">
+                      <a16:colId xmlns:a16="http://schemas.microsoft.com/office/drawing/2014/main" val="2619766692"/>
+                    </a:ext>
+                  </a:extLst>
+                </a:gridCol>
+                <a:gridCol w="1923504">
+                  <a:extLst>
+                    <a:ext uri="{9D8B030D-6E8A-4147-A177-3AD203B41FA5}">
+                      <a16:colId xmlns:a16="http://schemas.microsoft.com/office/drawing/2014/main" val="18921312"/>
+                    </a:ext>
+                  </a:extLst>
+                </a:gridCol>
+                <a:gridCol w="1923504">
+                  <a:extLst>
+                    <a:ext uri="{9D8B030D-6E8A-4147-A177-3AD203B41FA5}">
+                      <a16:colId xmlns:a16="http://schemas.microsoft.com/office/drawing/2014/main" val="1624438146"/>
+                    </a:ext>
+                  </a:extLst>
+                </a:gridCol>
+              </a:tblGrid>
+              <a:tr h="325981">
+                <a:tc>
+                  <a:txBody>
+                    <a:bodyPr/>
+                    <a:lstStyle/>
+                    <a:p>
+                      <a:pPr algn="l">
+                        <a:buNone/>
+                      </a:pPr>
+                      <a:endParaRPr lang="en-GB" sz="900" dirty="0">
+                        <a:effectLst/>
+                      </a:endParaRPr>
+                    </a:p>
+                  </a:txBody>
+                  <a:tcPr marL="40143" marR="40143" marT="40143" marB="40143" anchor="ctr">
+                    <a:lnL w="9525" cap="flat" cmpd="sng" algn="ctr">
+                      <a:solidFill>
+                        <a:srgbClr val="DDDDDD"/>
+                      </a:solidFill>
+                      <a:prstDash val="solid"/>
+                      <a:round/>
+                      <a:headEnd type="none" w="med" len="med"/>
+                      <a:tailEnd type="none" w="med" len="med"/>
+                    </a:lnL>
+                    <a:lnR w="9525" cap="flat" cmpd="sng" algn="ctr">
+                      <a:solidFill>
+                        <a:srgbClr val="DDDDDD"/>
+                      </a:solidFill>
+                      <a:prstDash val="solid"/>
+                      <a:round/>
+                      <a:headEnd type="none" w="med" len="med"/>
+                      <a:tailEnd type="none" w="med" len="med"/>
+                    </a:lnR>
+                    <a:lnT w="9525" cap="flat" cmpd="sng" algn="ctr">
+                      <a:solidFill>
+                        <a:srgbClr val="DDDDDD"/>
+                      </a:solidFill>
+                      <a:prstDash val="solid"/>
+                      <a:round/>
+                      <a:headEnd type="none" w="med" len="med"/>
+                      <a:tailEnd type="none" w="med" len="med"/>
+                    </a:lnT>
+                    <a:lnB w="9525" cap="flat" cmpd="sng" algn="ctr">
+                      <a:solidFill>
+                        <a:srgbClr val="DDDDDD"/>
+                      </a:solidFill>
+                      <a:prstDash val="solid"/>
+                      <a:round/>
+                      <a:headEnd type="none" w="med" len="med"/>
+                      <a:tailEnd type="none" w="med" len="med"/>
+                    </a:lnB>
+                    <a:solidFill>
+                      <a:srgbClr val="F2F2F2"/>
+                    </a:solidFill>
+                  </a:tcPr>
+                </a:tc>
+                <a:tc>
+                  <a:txBody>
+                    <a:bodyPr/>
+                    <a:lstStyle/>
+                    <a:p>
+                      <a:pPr algn="l">
+                        <a:buNone/>
+                      </a:pPr>
+                      <a:r>
+                        <a:rPr lang="en-GB" sz="900" dirty="0">
+                          <a:effectLst/>
+                        </a:rPr>
+                        <a:t>In Disk Table</a:t>
+                      </a:r>
+                    </a:p>
+                  </a:txBody>
+                  <a:tcPr marL="40143" marR="40143" marT="40143" marB="40143" anchor="ctr">
+                    <a:lnL w="9525" cap="flat" cmpd="sng" algn="ctr">
+                      <a:solidFill>
+                        <a:srgbClr val="DDDDDD"/>
+                      </a:solidFill>
+                      <a:prstDash val="solid"/>
+                      <a:round/>
+                      <a:headEnd type="none" w="med" len="med"/>
+                      <a:tailEnd type="none" w="med" len="med"/>
+                    </a:lnL>
+                    <a:lnR w="9525" cap="flat" cmpd="sng" algn="ctr">
+                      <a:solidFill>
+                        <a:srgbClr val="DDDDDD"/>
+                      </a:solidFill>
+                      <a:prstDash val="solid"/>
+                      <a:round/>
+                      <a:headEnd type="none" w="med" len="med"/>
+                      <a:tailEnd type="none" w="med" len="med"/>
+                    </a:lnR>
+                    <a:lnT w="9525" cap="flat" cmpd="sng" algn="ctr">
+                      <a:solidFill>
+                        <a:srgbClr val="DDDDDD"/>
+                      </a:solidFill>
+                      <a:prstDash val="solid"/>
+                      <a:round/>
+                      <a:headEnd type="none" w="med" len="med"/>
+                      <a:tailEnd type="none" w="med" len="med"/>
+                    </a:lnT>
+                    <a:lnB w="9525" cap="flat" cmpd="sng" algn="ctr">
+                      <a:solidFill>
+                        <a:srgbClr val="DDDDDD"/>
+                      </a:solidFill>
+                      <a:prstDash val="solid"/>
+                      <a:round/>
+                      <a:headEnd type="none" w="med" len="med"/>
+                      <a:tailEnd type="none" w="med" len="med"/>
+                    </a:lnB>
+                    <a:solidFill>
+                      <a:srgbClr val="F2F2F2"/>
+                    </a:solidFill>
+                  </a:tcPr>
+                </a:tc>
+                <a:tc>
+                  <a:txBody>
+                    <a:bodyPr/>
+                    <a:lstStyle/>
+                    <a:p>
+                      <a:pPr algn="l">
+                        <a:buNone/>
+                      </a:pPr>
+                      <a:r>
+                        <a:rPr lang="en-GB" sz="900" dirty="0">
+                          <a:effectLst/>
+                        </a:rPr>
+                        <a:t>In Memory Table</a:t>
+                      </a:r>
+                    </a:p>
+                  </a:txBody>
+                  <a:tcPr marL="40143" marR="40143" marT="40143" marB="40143" anchor="ctr">
+                    <a:lnL w="9525" cap="flat" cmpd="sng" algn="ctr">
+                      <a:solidFill>
+                        <a:srgbClr val="DDDDDD"/>
+                      </a:solidFill>
+                      <a:prstDash val="solid"/>
+                      <a:round/>
+                      <a:headEnd type="none" w="med" len="med"/>
+                      <a:tailEnd type="none" w="med" len="med"/>
+                    </a:lnL>
+                    <a:lnR w="9525" cap="flat" cmpd="sng" algn="ctr">
+                      <a:solidFill>
+                        <a:srgbClr val="DDDDDD"/>
+                      </a:solidFill>
+                      <a:prstDash val="solid"/>
+                      <a:round/>
+                      <a:headEnd type="none" w="med" len="med"/>
+                      <a:tailEnd type="none" w="med" len="med"/>
+                    </a:lnR>
+                    <a:lnT w="9525" cap="flat" cmpd="sng" algn="ctr">
+                      <a:solidFill>
+                        <a:srgbClr val="DDDDDD"/>
+                      </a:solidFill>
+                      <a:prstDash val="solid"/>
+                      <a:round/>
+                      <a:headEnd type="none" w="med" len="med"/>
+                      <a:tailEnd type="none" w="med" len="med"/>
+                    </a:lnT>
+                    <a:lnB w="9525" cap="flat" cmpd="sng" algn="ctr">
+                      <a:solidFill>
+                        <a:srgbClr val="DDDDDD"/>
+                      </a:solidFill>
+                      <a:prstDash val="solid"/>
+                      <a:round/>
+                      <a:headEnd type="none" w="med" len="med"/>
+                      <a:tailEnd type="none" w="med" len="med"/>
+                    </a:lnB>
+                    <a:solidFill>
+                      <a:srgbClr val="F2F2F2"/>
+                    </a:solidFill>
+                  </a:tcPr>
+                </a:tc>
+                <a:extLst>
+                  <a:ext uri="{0D108BD9-81ED-4DB2-BD59-A6C34878D82A}">
+                    <a16:rowId xmlns:a16="http://schemas.microsoft.com/office/drawing/2014/main" val="3852954944"/>
+                  </a:ext>
+                </a:extLst>
+              </a:tr>
+              <a:tr h="513826">
+                <a:tc>
+                  <a:txBody>
+                    <a:bodyPr/>
+                    <a:lstStyle/>
+                    <a:p>
+                      <a:pPr algn="l">
+                        <a:buNone/>
+                      </a:pPr>
+                      <a:r>
+                        <a:rPr lang="en-GB" sz="900">
+                          <a:effectLst/>
+                        </a:rPr>
+                        <a:t>Speicherort</a:t>
+                      </a:r>
+                    </a:p>
+                  </a:txBody>
+                  <a:tcPr marL="40143" marR="40143" marT="40143" marB="40143" anchor="ctr">
+                    <a:lnL w="9525" cap="flat" cmpd="sng" algn="ctr">
+                      <a:solidFill>
+                        <a:srgbClr val="DDDDDD"/>
+                      </a:solidFill>
+                      <a:prstDash val="solid"/>
+                      <a:round/>
+                      <a:headEnd type="none" w="med" len="med"/>
+                      <a:tailEnd type="none" w="med" len="med"/>
+                    </a:lnL>
+                    <a:lnR w="9525" cap="flat" cmpd="sng" algn="ctr">
+                      <a:solidFill>
+                        <a:srgbClr val="DDDDDD"/>
+                      </a:solidFill>
+                      <a:prstDash val="solid"/>
+                      <a:round/>
+                      <a:headEnd type="none" w="med" len="med"/>
+                      <a:tailEnd type="none" w="med" len="med"/>
+                    </a:lnR>
+                    <a:lnT w="9525" cap="flat" cmpd="sng" algn="ctr">
+                      <a:solidFill>
+                        <a:srgbClr val="DDDDDD"/>
+                      </a:solidFill>
+                      <a:prstDash val="solid"/>
+                      <a:round/>
+                      <a:headEnd type="none" w="med" len="med"/>
+                      <a:tailEnd type="none" w="med" len="med"/>
+                    </a:lnT>
+                    <a:lnB w="9525" cap="flat" cmpd="sng" algn="ctr">
+                      <a:solidFill>
+                        <a:srgbClr val="DDDDDD"/>
+                      </a:solidFill>
+                      <a:prstDash val="solid"/>
+                      <a:round/>
+                      <a:headEnd type="none" w="med" len="med"/>
+                      <a:tailEnd type="none" w="med" len="med"/>
+                    </a:lnB>
+                    <a:noFill/>
+                  </a:tcPr>
+                </a:tc>
+                <a:tc>
+                  <a:txBody>
+                    <a:bodyPr/>
+                    <a:lstStyle/>
+                    <a:p>
+                      <a:pPr algn="l">
+                        <a:buNone/>
+                      </a:pPr>
+                      <a:r>
+                        <a:rPr lang="de-DE" sz="900" dirty="0">
+                          <a:effectLst/>
+                        </a:rPr>
+                        <a:t>Seiten auf Datenträger, Buffer Cache im RAM</a:t>
+                      </a:r>
+                    </a:p>
+                  </a:txBody>
+                  <a:tcPr marL="40143" marR="40143" marT="40143" marB="40143" anchor="ctr">
+                    <a:lnL w="9525" cap="flat" cmpd="sng" algn="ctr">
+                      <a:solidFill>
+                        <a:srgbClr val="DDDDDD"/>
+                      </a:solidFill>
+                      <a:prstDash val="solid"/>
+                      <a:round/>
+                      <a:headEnd type="none" w="med" len="med"/>
+                      <a:tailEnd type="none" w="med" len="med"/>
+                    </a:lnL>
+                    <a:lnR w="9525" cap="flat" cmpd="sng" algn="ctr">
+                      <a:solidFill>
+                        <a:srgbClr val="DDDDDD"/>
+                      </a:solidFill>
+                      <a:prstDash val="solid"/>
+                      <a:round/>
+                      <a:headEnd type="none" w="med" len="med"/>
+                      <a:tailEnd type="none" w="med" len="med"/>
+                    </a:lnR>
+                    <a:lnT w="9525" cap="flat" cmpd="sng" algn="ctr">
+                      <a:solidFill>
+                        <a:srgbClr val="DDDDDD"/>
+                      </a:solidFill>
+                      <a:prstDash val="solid"/>
+                      <a:round/>
+                      <a:headEnd type="none" w="med" len="med"/>
+                      <a:tailEnd type="none" w="med" len="med"/>
+                    </a:lnT>
+                    <a:lnB w="9525" cap="flat" cmpd="sng" algn="ctr">
+                      <a:solidFill>
+                        <a:srgbClr val="DDDDDD"/>
+                      </a:solidFill>
+                      <a:prstDash val="solid"/>
+                      <a:round/>
+                      <a:headEnd type="none" w="med" len="med"/>
+                      <a:tailEnd type="none" w="med" len="med"/>
+                    </a:lnB>
+                    <a:noFill/>
+                  </a:tcPr>
+                </a:tc>
+                <a:tc>
+                  <a:txBody>
+                    <a:bodyPr/>
+                    <a:lstStyle/>
+                    <a:p>
+                      <a:pPr algn="l">
+                        <a:buNone/>
+                      </a:pPr>
+                      <a:r>
+                        <a:rPr lang="de-DE" sz="900" dirty="0">
+                          <a:effectLst/>
+                        </a:rPr>
+                        <a:t>Daten dauerhaft im RAM, Log/Daten/Delta auf Disk</a:t>
+                      </a:r>
+                    </a:p>
+                  </a:txBody>
+                  <a:tcPr marL="40143" marR="40143" marT="40143" marB="40143" anchor="ctr">
+                    <a:lnL w="9525" cap="flat" cmpd="sng" algn="ctr">
+                      <a:solidFill>
+                        <a:srgbClr val="DDDDDD"/>
+                      </a:solidFill>
+                      <a:prstDash val="solid"/>
+                      <a:round/>
+                      <a:headEnd type="none" w="med" len="med"/>
+                      <a:tailEnd type="none" w="med" len="med"/>
+                    </a:lnL>
+                    <a:lnR w="9525" cap="flat" cmpd="sng" algn="ctr">
+                      <a:solidFill>
+                        <a:srgbClr val="DDDDDD"/>
+                      </a:solidFill>
+                      <a:prstDash val="solid"/>
+                      <a:round/>
+                      <a:headEnd type="none" w="med" len="med"/>
+                      <a:tailEnd type="none" w="med" len="med"/>
+                    </a:lnR>
+                    <a:lnT w="9525" cap="flat" cmpd="sng" algn="ctr">
+                      <a:solidFill>
+                        <a:srgbClr val="DDDDDD"/>
+                      </a:solidFill>
+                      <a:prstDash val="solid"/>
+                      <a:round/>
+                      <a:headEnd type="none" w="med" len="med"/>
+                      <a:tailEnd type="none" w="med" len="med"/>
+                    </a:lnT>
+                    <a:lnB w="9525" cap="flat" cmpd="sng" algn="ctr">
+                      <a:solidFill>
+                        <a:srgbClr val="DDDDDD"/>
+                      </a:solidFill>
+                      <a:prstDash val="solid"/>
+                      <a:round/>
+                      <a:headEnd type="none" w="med" len="med"/>
+                      <a:tailEnd type="none" w="med" len="med"/>
+                    </a:lnB>
+                    <a:noFill/>
+                  </a:tcPr>
+                </a:tc>
+                <a:extLst>
+                  <a:ext uri="{0D108BD9-81ED-4DB2-BD59-A6C34878D82A}">
+                    <a16:rowId xmlns:a16="http://schemas.microsoft.com/office/drawing/2014/main" val="3048235710"/>
+                  </a:ext>
+                </a:extLst>
+              </a:tr>
+              <a:tr h="513826">
+                <a:tc>
+                  <a:txBody>
+                    <a:bodyPr/>
+                    <a:lstStyle/>
+                    <a:p>
+                      <a:pPr algn="l">
+                        <a:buNone/>
+                      </a:pPr>
+                      <a:r>
+                        <a:rPr lang="en-GB" sz="900">
+                          <a:effectLst/>
+                        </a:rPr>
+                        <a:t>Struktur</a:t>
+                      </a:r>
+                    </a:p>
+                  </a:txBody>
+                  <a:tcPr marL="40143" marR="40143" marT="40143" marB="40143" anchor="ctr">
+                    <a:lnL w="9525" cap="flat" cmpd="sng" algn="ctr">
+                      <a:solidFill>
+                        <a:srgbClr val="DDDDDD"/>
+                      </a:solidFill>
+                      <a:prstDash val="solid"/>
+                      <a:round/>
+                      <a:headEnd type="none" w="med" len="med"/>
+                      <a:tailEnd type="none" w="med" len="med"/>
+                    </a:lnL>
+                    <a:lnR w="9525" cap="flat" cmpd="sng" algn="ctr">
+                      <a:solidFill>
+                        <a:srgbClr val="DDDDDD"/>
+                      </a:solidFill>
+                      <a:prstDash val="solid"/>
+                      <a:round/>
+                      <a:headEnd type="none" w="med" len="med"/>
+                      <a:tailEnd type="none" w="med" len="med"/>
+                    </a:lnR>
+                    <a:lnT w="9525" cap="flat" cmpd="sng" algn="ctr">
+                      <a:solidFill>
+                        <a:srgbClr val="DDDDDD"/>
+                      </a:solidFill>
+                      <a:prstDash val="solid"/>
+                      <a:round/>
+                      <a:headEnd type="none" w="med" len="med"/>
+                      <a:tailEnd type="none" w="med" len="med"/>
+                    </a:lnT>
+                    <a:lnB w="9525" cap="flat" cmpd="sng" algn="ctr">
+                      <a:solidFill>
+                        <a:srgbClr val="DDDDDD"/>
+                      </a:solidFill>
+                      <a:prstDash val="solid"/>
+                      <a:round/>
+                      <a:headEnd type="none" w="med" len="med"/>
+                      <a:tailEnd type="none" w="med" len="med"/>
+                    </a:lnB>
+                    <a:noFill/>
+                  </a:tcPr>
+                </a:tc>
+                <a:tc>
+                  <a:txBody>
+                    <a:bodyPr/>
+                    <a:lstStyle/>
+                    <a:p>
+                      <a:pPr algn="l">
+                        <a:buNone/>
+                      </a:pPr>
+                      <a:r>
+                        <a:rPr lang="de-DE" sz="900" dirty="0">
+                          <a:effectLst/>
+                        </a:rPr>
+                        <a:t>8‑KB‑Seiten, eine Seite pro Tabelle</a:t>
+                      </a:r>
+                    </a:p>
+                  </a:txBody>
+                  <a:tcPr marL="40143" marR="40143" marT="40143" marB="40143" anchor="ctr">
+                    <a:lnL w="9525" cap="flat" cmpd="sng" algn="ctr">
+                      <a:solidFill>
+                        <a:srgbClr val="DDDDDD"/>
+                      </a:solidFill>
+                      <a:prstDash val="solid"/>
+                      <a:round/>
+                      <a:headEnd type="none" w="med" len="med"/>
+                      <a:tailEnd type="none" w="med" len="med"/>
+                    </a:lnL>
+                    <a:lnR w="9525" cap="flat" cmpd="sng" algn="ctr">
+                      <a:solidFill>
+                        <a:srgbClr val="DDDDDD"/>
+                      </a:solidFill>
+                      <a:prstDash val="solid"/>
+                      <a:round/>
+                      <a:headEnd type="none" w="med" len="med"/>
+                      <a:tailEnd type="none" w="med" len="med"/>
+                    </a:lnR>
+                    <a:lnT w="9525" cap="flat" cmpd="sng" algn="ctr">
+                      <a:solidFill>
+                        <a:srgbClr val="DDDDDD"/>
+                      </a:solidFill>
+                      <a:prstDash val="solid"/>
+                      <a:round/>
+                      <a:headEnd type="none" w="med" len="med"/>
+                      <a:tailEnd type="none" w="med" len="med"/>
+                    </a:lnT>
+                    <a:lnB w="9525" cap="flat" cmpd="sng" algn="ctr">
+                      <a:solidFill>
+                        <a:srgbClr val="DDDDDD"/>
+                      </a:solidFill>
+                      <a:prstDash val="solid"/>
+                      <a:round/>
+                      <a:headEnd type="none" w="med" len="med"/>
+                      <a:tailEnd type="none" w="med" len="med"/>
+                    </a:lnB>
+                    <a:noFill/>
+                  </a:tcPr>
+                </a:tc>
+                <a:tc>
+                  <a:txBody>
+                    <a:bodyPr/>
+                    <a:lstStyle/>
+                    <a:p>
+                      <a:pPr algn="l">
+                        <a:buNone/>
+                      </a:pPr>
+                      <a:r>
+                        <a:rPr lang="de-DE" sz="900" dirty="0">
+                          <a:effectLst/>
+                        </a:rPr>
+                        <a:t>Zeilenbasiert, keine Seiten, Files können Zeilen mehrerer Tabellen enthalten. </a:t>
+                      </a:r>
+                    </a:p>
+                  </a:txBody>
+                  <a:tcPr marL="40143" marR="40143" marT="40143" marB="40143" anchor="ctr">
+                    <a:lnL w="9525" cap="flat" cmpd="sng" algn="ctr">
+                      <a:solidFill>
+                        <a:srgbClr val="DDDDDD"/>
+                      </a:solidFill>
+                      <a:prstDash val="solid"/>
+                      <a:round/>
+                      <a:headEnd type="none" w="med" len="med"/>
+                      <a:tailEnd type="none" w="med" len="med"/>
+                    </a:lnL>
+                    <a:lnR w="9525" cap="flat" cmpd="sng" algn="ctr">
+                      <a:solidFill>
+                        <a:srgbClr val="DDDDDD"/>
+                      </a:solidFill>
+                      <a:prstDash val="solid"/>
+                      <a:round/>
+                      <a:headEnd type="none" w="med" len="med"/>
+                      <a:tailEnd type="none" w="med" len="med"/>
+                    </a:lnR>
+                    <a:lnT w="9525" cap="flat" cmpd="sng" algn="ctr">
+                      <a:solidFill>
+                        <a:srgbClr val="DDDDDD"/>
+                      </a:solidFill>
+                      <a:prstDash val="solid"/>
+                      <a:round/>
+                      <a:headEnd type="none" w="med" len="med"/>
+                      <a:tailEnd type="none" w="med" len="med"/>
+                    </a:lnT>
+                    <a:lnB w="9525" cap="flat" cmpd="sng" algn="ctr">
+                      <a:solidFill>
+                        <a:srgbClr val="DDDDDD"/>
+                      </a:solidFill>
+                      <a:prstDash val="solid"/>
+                      <a:round/>
+                      <a:headEnd type="none" w="med" len="med"/>
+                      <a:tailEnd type="none" w="med" len="med"/>
+                    </a:lnB>
+                    <a:noFill/>
+                  </a:tcPr>
+                </a:tc>
+                <a:extLst>
+                  <a:ext uri="{0D108BD9-81ED-4DB2-BD59-A6C34878D82A}">
+                    <a16:rowId xmlns:a16="http://schemas.microsoft.com/office/drawing/2014/main" val="4219890668"/>
+                  </a:ext>
+                </a:extLst>
+              </a:tr>
+              <a:tr h="658340">
+                <a:tc>
+                  <a:txBody>
+                    <a:bodyPr/>
+                    <a:lstStyle/>
+                    <a:p>
+                      <a:pPr algn="l">
+                        <a:buNone/>
+                      </a:pPr>
+                      <a:r>
+                        <a:rPr lang="en-GB" sz="900">
+                          <a:effectLst/>
+                        </a:rPr>
+                        <a:t>Indizes</a:t>
+                      </a:r>
+                    </a:p>
+                  </a:txBody>
+                  <a:tcPr marL="40143" marR="40143" marT="40143" marB="40143" anchor="ctr">
+                    <a:lnL w="9525" cap="flat" cmpd="sng" algn="ctr">
+                      <a:solidFill>
+                        <a:srgbClr val="DDDDDD"/>
+                      </a:solidFill>
+                      <a:prstDash val="solid"/>
+                      <a:round/>
+                      <a:headEnd type="none" w="med" len="med"/>
+                      <a:tailEnd type="none" w="med" len="med"/>
+                    </a:lnL>
+                    <a:lnR w="9525" cap="flat" cmpd="sng" algn="ctr">
+                      <a:solidFill>
+                        <a:srgbClr val="DDDDDD"/>
+                      </a:solidFill>
+                      <a:prstDash val="solid"/>
+                      <a:round/>
+                      <a:headEnd type="none" w="med" len="med"/>
+                      <a:tailEnd type="none" w="med" len="med"/>
+                    </a:lnR>
+                    <a:lnT w="9525" cap="flat" cmpd="sng" algn="ctr">
+                      <a:solidFill>
+                        <a:srgbClr val="DDDDDD"/>
+                      </a:solidFill>
+                      <a:prstDash val="solid"/>
+                      <a:round/>
+                      <a:headEnd type="none" w="med" len="med"/>
+                      <a:tailEnd type="none" w="med" len="med"/>
+                    </a:lnT>
+                    <a:lnB w="9525" cap="flat" cmpd="sng" algn="ctr">
+                      <a:solidFill>
+                        <a:srgbClr val="DDDDDD"/>
+                      </a:solidFill>
+                      <a:prstDash val="solid"/>
+                      <a:round/>
+                      <a:headEnd type="none" w="med" len="med"/>
+                      <a:tailEnd type="none" w="med" len="med"/>
+                    </a:lnB>
+                    <a:noFill/>
+                  </a:tcPr>
+                </a:tc>
+                <a:tc>
+                  <a:txBody>
+                    <a:bodyPr/>
+                    <a:lstStyle/>
+                    <a:p>
+                      <a:pPr algn="l">
+                        <a:buNone/>
+                      </a:pPr>
+                      <a:r>
+                        <a:rPr lang="en-GB" sz="900" dirty="0" err="1">
+                          <a:effectLst/>
+                        </a:rPr>
+                        <a:t>Persistierte</a:t>
+                      </a:r>
+                      <a:r>
+                        <a:rPr lang="en-GB" sz="900" dirty="0">
+                          <a:effectLst/>
+                        </a:rPr>
+                        <a:t> </a:t>
+                      </a:r>
+                      <a:r>
+                        <a:rPr lang="en-GB" sz="900" dirty="0" err="1">
+                          <a:effectLst/>
+                        </a:rPr>
+                        <a:t>Indexseiten</a:t>
+                      </a:r>
+                      <a:r>
+                        <a:rPr lang="en-GB" sz="900" dirty="0">
+                          <a:effectLst/>
+                        </a:rPr>
+                        <a:t>, </a:t>
+                      </a:r>
+                      <a:r>
+                        <a:rPr lang="en-GB" sz="900" dirty="0" err="1">
+                          <a:effectLst/>
+                        </a:rPr>
+                        <a:t>voll</a:t>
+                      </a:r>
+                      <a:r>
+                        <a:rPr lang="en-GB" sz="900" dirty="0">
+                          <a:effectLst/>
+                        </a:rPr>
+                        <a:t> </a:t>
+                      </a:r>
+                      <a:r>
+                        <a:rPr lang="en-GB" sz="900" dirty="0" err="1">
+                          <a:effectLst/>
+                        </a:rPr>
+                        <a:t>geloggt</a:t>
+                      </a:r>
+                      <a:r>
+                        <a:rPr lang="en-GB" sz="900" dirty="0">
+                          <a:effectLst/>
+                        </a:rPr>
+                        <a:t>.</a:t>
+                      </a:r>
+                    </a:p>
+                  </a:txBody>
+                  <a:tcPr marL="40143" marR="40143" marT="40143" marB="40143" anchor="ctr">
+                    <a:lnL w="9525" cap="flat" cmpd="sng" algn="ctr">
+                      <a:solidFill>
+                        <a:srgbClr val="DDDDDD"/>
+                      </a:solidFill>
+                      <a:prstDash val="solid"/>
+                      <a:round/>
+                      <a:headEnd type="none" w="med" len="med"/>
+                      <a:tailEnd type="none" w="med" len="med"/>
+                    </a:lnL>
+                    <a:lnR w="9525" cap="flat" cmpd="sng" algn="ctr">
+                      <a:solidFill>
+                        <a:srgbClr val="DDDDDD"/>
+                      </a:solidFill>
+                      <a:prstDash val="solid"/>
+                      <a:round/>
+                      <a:headEnd type="none" w="med" len="med"/>
+                      <a:tailEnd type="none" w="med" len="med"/>
+                    </a:lnR>
+                    <a:lnT w="9525" cap="flat" cmpd="sng" algn="ctr">
+                      <a:solidFill>
+                        <a:srgbClr val="DDDDDD"/>
+                      </a:solidFill>
+                      <a:prstDash val="solid"/>
+                      <a:round/>
+                      <a:headEnd type="none" w="med" len="med"/>
+                      <a:tailEnd type="none" w="med" len="med"/>
+                    </a:lnT>
+                    <a:lnB w="9525" cap="flat" cmpd="sng" algn="ctr">
+                      <a:solidFill>
+                        <a:srgbClr val="DDDDDD"/>
+                      </a:solidFill>
+                      <a:prstDash val="solid"/>
+                      <a:round/>
+                      <a:headEnd type="none" w="med" len="med"/>
+                      <a:tailEnd type="none" w="med" len="med"/>
+                    </a:lnB>
+                    <a:noFill/>
+                  </a:tcPr>
+                </a:tc>
+                <a:tc>
+                  <a:txBody>
+                    <a:bodyPr/>
+                    <a:lstStyle/>
+                    <a:p>
+                      <a:pPr algn="l">
+                        <a:buNone/>
+                      </a:pPr>
+                      <a:r>
+                        <a:rPr lang="en-GB" sz="900" dirty="0">
+                          <a:effectLst/>
+                        </a:rPr>
+                        <a:t>Nur Definition persistent, Index </a:t>
+                      </a:r>
+                      <a:r>
+                        <a:rPr lang="en-GB" sz="900" dirty="0" err="1">
+                          <a:effectLst/>
+                        </a:rPr>
+                        <a:t>im</a:t>
+                      </a:r>
+                      <a:r>
+                        <a:rPr lang="en-GB" sz="900" dirty="0">
+                          <a:effectLst/>
+                        </a:rPr>
+                        <a:t> RAM, </a:t>
+                      </a:r>
+                      <a:r>
+                        <a:rPr lang="en-GB" sz="900" dirty="0" err="1">
+                          <a:effectLst/>
+                        </a:rPr>
+                        <a:t>kein</a:t>
+                      </a:r>
+                      <a:r>
+                        <a:rPr lang="en-GB" sz="900" dirty="0">
+                          <a:effectLst/>
+                        </a:rPr>
+                        <a:t> Logging der Index‑</a:t>
+                      </a:r>
+                      <a:r>
+                        <a:rPr lang="en-GB" sz="900" dirty="0" err="1">
+                          <a:effectLst/>
+                        </a:rPr>
+                        <a:t>Zeilen</a:t>
+                      </a:r>
+                      <a:endParaRPr lang="en-GB" sz="900" dirty="0">
+                        <a:effectLst/>
+                      </a:endParaRPr>
+                    </a:p>
+                  </a:txBody>
+                  <a:tcPr marL="40143" marR="40143" marT="40143" marB="40143" anchor="ctr">
+                    <a:lnL w="9525" cap="flat" cmpd="sng" algn="ctr">
+                      <a:solidFill>
+                        <a:srgbClr val="DDDDDD"/>
+                      </a:solidFill>
+                      <a:prstDash val="solid"/>
+                      <a:round/>
+                      <a:headEnd type="none" w="med" len="med"/>
+                      <a:tailEnd type="none" w="med" len="med"/>
+                    </a:lnL>
+                    <a:lnR w="9525" cap="flat" cmpd="sng" algn="ctr">
+                      <a:solidFill>
+                        <a:srgbClr val="DDDDDD"/>
+                      </a:solidFill>
+                      <a:prstDash val="solid"/>
+                      <a:round/>
+                      <a:headEnd type="none" w="med" len="med"/>
+                      <a:tailEnd type="none" w="med" len="med"/>
+                    </a:lnR>
+                    <a:lnT w="9525" cap="flat" cmpd="sng" algn="ctr">
+                      <a:solidFill>
+                        <a:srgbClr val="DDDDDD"/>
+                      </a:solidFill>
+                      <a:prstDash val="solid"/>
+                      <a:round/>
+                      <a:headEnd type="none" w="med" len="med"/>
+                      <a:tailEnd type="none" w="med" len="med"/>
+                    </a:lnT>
+                    <a:lnB w="9525" cap="flat" cmpd="sng" algn="ctr">
+                      <a:solidFill>
+                        <a:srgbClr val="DDDDDD"/>
+                      </a:solidFill>
+                      <a:prstDash val="solid"/>
+                      <a:round/>
+                      <a:headEnd type="none" w="med" len="med"/>
+                      <a:tailEnd type="none" w="med" len="med"/>
+                    </a:lnB>
+                    <a:noFill/>
+                  </a:tcPr>
+                </a:tc>
+                <a:extLst>
+                  <a:ext uri="{0D108BD9-81ED-4DB2-BD59-A6C34878D82A}">
+                    <a16:rowId xmlns:a16="http://schemas.microsoft.com/office/drawing/2014/main" val="3453355456"/>
+                  </a:ext>
+                </a:extLst>
+              </a:tr>
+              <a:tr h="658340">
+                <a:tc>
+                  <a:txBody>
+                    <a:bodyPr/>
+                    <a:lstStyle/>
+                    <a:p>
+                      <a:pPr algn="l">
+                        <a:buNone/>
+                      </a:pPr>
+                      <a:r>
+                        <a:rPr lang="en-GB" sz="900" dirty="0" err="1">
+                          <a:effectLst/>
+                        </a:rPr>
+                        <a:t>DML</a:t>
+                      </a:r>
+                      <a:r>
+                        <a:rPr lang="en-GB" sz="900" dirty="0">
+                          <a:effectLst/>
+                        </a:rPr>
+                        <a:t> (Data Manipulation Language)</a:t>
+                      </a:r>
+                    </a:p>
+                  </a:txBody>
+                  <a:tcPr marL="40143" marR="40143" marT="40143" marB="40143" anchor="ctr">
+                    <a:lnL w="9525" cap="flat" cmpd="sng" algn="ctr">
+                      <a:solidFill>
+                        <a:srgbClr val="DDDDDD"/>
+                      </a:solidFill>
+                      <a:prstDash val="solid"/>
+                      <a:round/>
+                      <a:headEnd type="none" w="med" len="med"/>
+                      <a:tailEnd type="none" w="med" len="med"/>
+                    </a:lnL>
+                    <a:lnR w="9525" cap="flat" cmpd="sng" algn="ctr">
+                      <a:solidFill>
+                        <a:srgbClr val="DDDDDD"/>
+                      </a:solidFill>
+                      <a:prstDash val="solid"/>
+                      <a:round/>
+                      <a:headEnd type="none" w="med" len="med"/>
+                      <a:tailEnd type="none" w="med" len="med"/>
+                    </a:lnR>
+                    <a:lnT w="9525" cap="flat" cmpd="sng" algn="ctr">
+                      <a:solidFill>
+                        <a:srgbClr val="DDDDDD"/>
+                      </a:solidFill>
+                      <a:prstDash val="solid"/>
+                      <a:round/>
+                      <a:headEnd type="none" w="med" len="med"/>
+                      <a:tailEnd type="none" w="med" len="med"/>
+                    </a:lnT>
+                    <a:lnB w="9525" cap="flat" cmpd="sng" algn="ctr">
+                      <a:solidFill>
+                        <a:srgbClr val="DDDDDD"/>
+                      </a:solidFill>
+                      <a:prstDash val="solid"/>
+                      <a:round/>
+                      <a:headEnd type="none" w="med" len="med"/>
+                      <a:tailEnd type="none" w="med" len="med"/>
+                    </a:lnB>
+                    <a:noFill/>
+                  </a:tcPr>
+                </a:tc>
+                <a:tc>
+                  <a:txBody>
+                    <a:bodyPr/>
+                    <a:lstStyle/>
+                    <a:p>
+                      <a:pPr algn="l">
+                        <a:buNone/>
+                      </a:pPr>
+                      <a:r>
+                        <a:rPr lang="de-DE" sz="900" dirty="0">
+                          <a:effectLst/>
+                        </a:rPr>
+                        <a:t>Seiten laden, auf Seite ändern, Seiten zurückschreiben. </a:t>
+                      </a:r>
+                    </a:p>
+                  </a:txBody>
+                  <a:tcPr marL="40143" marR="40143" marT="40143" marB="40143" anchor="ctr">
+                    <a:lnL w="9525" cap="flat" cmpd="sng" algn="ctr">
+                      <a:solidFill>
+                        <a:srgbClr val="DDDDDD"/>
+                      </a:solidFill>
+                      <a:prstDash val="solid"/>
+                      <a:round/>
+                      <a:headEnd type="none" w="med" len="med"/>
+                      <a:tailEnd type="none" w="med" len="med"/>
+                    </a:lnL>
+                    <a:lnR w="9525" cap="flat" cmpd="sng" algn="ctr">
+                      <a:solidFill>
+                        <a:srgbClr val="DDDDDD"/>
+                      </a:solidFill>
+                      <a:prstDash val="solid"/>
+                      <a:round/>
+                      <a:headEnd type="none" w="med" len="med"/>
+                      <a:tailEnd type="none" w="med" len="med"/>
+                    </a:lnR>
+                    <a:lnT w="9525" cap="flat" cmpd="sng" algn="ctr">
+                      <a:solidFill>
+                        <a:srgbClr val="DDDDDD"/>
+                      </a:solidFill>
+                      <a:prstDash val="solid"/>
+                      <a:round/>
+                      <a:headEnd type="none" w="med" len="med"/>
+                      <a:tailEnd type="none" w="med" len="med"/>
+                    </a:lnT>
+                    <a:lnB w="9525" cap="flat" cmpd="sng" algn="ctr">
+                      <a:solidFill>
+                        <a:srgbClr val="DDDDDD"/>
+                      </a:solidFill>
+                      <a:prstDash val="solid"/>
+                      <a:round/>
+                      <a:headEnd type="none" w="med" len="med"/>
+                      <a:tailEnd type="none" w="med" len="med"/>
+                    </a:lnB>
+                    <a:noFill/>
+                  </a:tcPr>
+                </a:tc>
+                <a:tc>
+                  <a:txBody>
+                    <a:bodyPr/>
+                    <a:lstStyle/>
+                    <a:p>
+                      <a:pPr algn="l">
+                        <a:buNone/>
+                      </a:pPr>
+                      <a:r>
+                        <a:rPr lang="de-DE" sz="900" dirty="0">
+                          <a:effectLst/>
+                        </a:rPr>
+                        <a:t>Direkt im RAM, Log‑Thread schreibt Daten/Delta‑Dateien.</a:t>
+                      </a:r>
+                    </a:p>
+                  </a:txBody>
+                  <a:tcPr marL="40143" marR="40143" marT="40143" marB="40143" anchor="ctr">
+                    <a:lnL w="9525" cap="flat" cmpd="sng" algn="ctr">
+                      <a:solidFill>
+                        <a:srgbClr val="DDDDDD"/>
+                      </a:solidFill>
+                      <a:prstDash val="solid"/>
+                      <a:round/>
+                      <a:headEnd type="none" w="med" len="med"/>
+                      <a:tailEnd type="none" w="med" len="med"/>
+                    </a:lnL>
+                    <a:lnR w="9525" cap="flat" cmpd="sng" algn="ctr">
+                      <a:solidFill>
+                        <a:srgbClr val="DDDDDD"/>
+                      </a:solidFill>
+                      <a:prstDash val="solid"/>
+                      <a:round/>
+                      <a:headEnd type="none" w="med" len="med"/>
+                      <a:tailEnd type="none" w="med" len="med"/>
+                    </a:lnR>
+                    <a:lnT w="9525" cap="flat" cmpd="sng" algn="ctr">
+                      <a:solidFill>
+                        <a:srgbClr val="DDDDDD"/>
+                      </a:solidFill>
+                      <a:prstDash val="solid"/>
+                      <a:round/>
+                      <a:headEnd type="none" w="med" len="med"/>
+                      <a:tailEnd type="none" w="med" len="med"/>
+                    </a:lnT>
+                    <a:lnB w="9525" cap="flat" cmpd="sng" algn="ctr">
+                      <a:solidFill>
+                        <a:srgbClr val="DDDDDD"/>
+                      </a:solidFill>
+                      <a:prstDash val="solid"/>
+                      <a:round/>
+                      <a:headEnd type="none" w="med" len="med"/>
+                      <a:tailEnd type="none" w="med" len="med"/>
+                    </a:lnB>
+                    <a:noFill/>
+                  </a:tcPr>
+                </a:tc>
+                <a:extLst>
+                  <a:ext uri="{0D108BD9-81ED-4DB2-BD59-A6C34878D82A}">
+                    <a16:rowId xmlns:a16="http://schemas.microsoft.com/office/drawing/2014/main" val="1493453244"/>
+                  </a:ext>
+                </a:extLst>
+              </a:tr>
+              <a:tr h="369313">
+                <a:tc>
+                  <a:txBody>
+                    <a:bodyPr/>
+                    <a:lstStyle/>
+                    <a:p>
+                      <a:pPr algn="l">
+                        <a:buNone/>
+                      </a:pPr>
+                      <a:r>
+                        <a:rPr lang="en-GB" sz="900">
+                          <a:effectLst/>
+                        </a:rPr>
+                        <a:t>Concurrency</a:t>
+                      </a:r>
+                    </a:p>
+                  </a:txBody>
+                  <a:tcPr marL="40143" marR="40143" marT="40143" marB="40143" anchor="ctr">
+                    <a:lnL w="9525" cap="flat" cmpd="sng" algn="ctr">
+                      <a:solidFill>
+                        <a:srgbClr val="DDDDDD"/>
+                      </a:solidFill>
+                      <a:prstDash val="solid"/>
+                      <a:round/>
+                      <a:headEnd type="none" w="med" len="med"/>
+                      <a:tailEnd type="none" w="med" len="med"/>
+                    </a:lnL>
+                    <a:lnR w="9525" cap="flat" cmpd="sng" algn="ctr">
+                      <a:solidFill>
+                        <a:srgbClr val="DDDDDD"/>
+                      </a:solidFill>
+                      <a:prstDash val="solid"/>
+                      <a:round/>
+                      <a:headEnd type="none" w="med" len="med"/>
+                      <a:tailEnd type="none" w="med" len="med"/>
+                    </a:lnR>
+                    <a:lnT w="9525" cap="flat" cmpd="sng" algn="ctr">
+                      <a:solidFill>
+                        <a:srgbClr val="DDDDDD"/>
+                      </a:solidFill>
+                      <a:prstDash val="solid"/>
+                      <a:round/>
+                      <a:headEnd type="none" w="med" len="med"/>
+                      <a:tailEnd type="none" w="med" len="med"/>
+                    </a:lnT>
+                    <a:lnB w="9525" cap="flat" cmpd="sng" algn="ctr">
+                      <a:solidFill>
+                        <a:srgbClr val="DDDDDD"/>
+                      </a:solidFill>
+                      <a:prstDash val="solid"/>
+                      <a:round/>
+                      <a:headEnd type="none" w="med" len="med"/>
+                      <a:tailEnd type="none" w="med" len="med"/>
+                    </a:lnB>
+                    <a:noFill/>
+                  </a:tcPr>
+                </a:tc>
+                <a:tc>
+                  <a:txBody>
+                    <a:bodyPr/>
+                    <a:lstStyle/>
+                    <a:p>
+                      <a:pPr algn="l">
+                        <a:buNone/>
+                      </a:pPr>
+                      <a:r>
+                        <a:rPr lang="de-DE" sz="900" dirty="0">
+                          <a:effectLst/>
+                        </a:rPr>
+                        <a:t>Locks und Latches, potenziell Blockierungen.</a:t>
+                      </a:r>
+                    </a:p>
+                  </a:txBody>
+                  <a:tcPr marL="40143" marR="40143" marT="40143" marB="40143" anchor="ctr">
+                    <a:lnL w="9525" cap="flat" cmpd="sng" algn="ctr">
+                      <a:solidFill>
+                        <a:srgbClr val="DDDDDD"/>
+                      </a:solidFill>
+                      <a:prstDash val="solid"/>
+                      <a:round/>
+                      <a:headEnd type="none" w="med" len="med"/>
+                      <a:tailEnd type="none" w="med" len="med"/>
+                    </a:lnL>
+                    <a:lnR w="9525" cap="flat" cmpd="sng" algn="ctr">
+                      <a:solidFill>
+                        <a:srgbClr val="DDDDDD"/>
+                      </a:solidFill>
+                      <a:prstDash val="solid"/>
+                      <a:round/>
+                      <a:headEnd type="none" w="med" len="med"/>
+                      <a:tailEnd type="none" w="med" len="med"/>
+                    </a:lnR>
+                    <a:lnT w="9525" cap="flat" cmpd="sng" algn="ctr">
+                      <a:solidFill>
+                        <a:srgbClr val="DDDDDD"/>
+                      </a:solidFill>
+                      <a:prstDash val="solid"/>
+                      <a:round/>
+                      <a:headEnd type="none" w="med" len="med"/>
+                      <a:tailEnd type="none" w="med" len="med"/>
+                    </a:lnT>
+                    <a:lnB w="9525" cap="flat" cmpd="sng" algn="ctr">
+                      <a:solidFill>
+                        <a:srgbClr val="DDDDDD"/>
+                      </a:solidFill>
+                      <a:prstDash val="solid"/>
+                      <a:round/>
+                      <a:headEnd type="none" w="med" len="med"/>
+                      <a:tailEnd type="none" w="med" len="med"/>
+                    </a:lnB>
+                    <a:noFill/>
+                  </a:tcPr>
+                </a:tc>
+                <a:tc>
+                  <a:txBody>
+                    <a:bodyPr/>
+                    <a:lstStyle/>
+                    <a:p>
+                      <a:pPr algn="l">
+                        <a:buNone/>
+                      </a:pPr>
+                      <a:r>
+                        <a:rPr lang="de-DE" sz="900" dirty="0">
+                          <a:effectLst/>
+                        </a:rPr>
+                        <a:t>Lock‑freie Strukturen, optimistisches </a:t>
+                      </a:r>
+                      <a:r>
+                        <a:rPr lang="de-DE" sz="900" dirty="0" err="1">
+                          <a:effectLst/>
+                        </a:rPr>
+                        <a:t>MVCC</a:t>
+                      </a:r>
+                      <a:endParaRPr lang="de-DE" sz="900" dirty="0">
+                        <a:effectLst/>
+                      </a:endParaRPr>
+                    </a:p>
+                  </a:txBody>
+                  <a:tcPr marL="40143" marR="40143" marT="40143" marB="40143" anchor="ctr">
+                    <a:lnL w="9525" cap="flat" cmpd="sng" algn="ctr">
+                      <a:solidFill>
+                        <a:srgbClr val="DDDDDD"/>
+                      </a:solidFill>
+                      <a:prstDash val="solid"/>
+                      <a:round/>
+                      <a:headEnd type="none" w="med" len="med"/>
+                      <a:tailEnd type="none" w="med" len="med"/>
+                    </a:lnL>
+                    <a:lnR w="9525" cap="flat" cmpd="sng" algn="ctr">
+                      <a:solidFill>
+                        <a:srgbClr val="DDDDDD"/>
+                      </a:solidFill>
+                      <a:prstDash val="solid"/>
+                      <a:round/>
+                      <a:headEnd type="none" w="med" len="med"/>
+                      <a:tailEnd type="none" w="med" len="med"/>
+                    </a:lnR>
+                    <a:lnT w="9525" cap="flat" cmpd="sng" algn="ctr">
+                      <a:solidFill>
+                        <a:srgbClr val="DDDDDD"/>
+                      </a:solidFill>
+                      <a:prstDash val="solid"/>
+                      <a:round/>
+                      <a:headEnd type="none" w="med" len="med"/>
+                      <a:tailEnd type="none" w="med" len="med"/>
+                    </a:lnT>
+                    <a:lnB w="9525" cap="flat" cmpd="sng" algn="ctr">
+                      <a:solidFill>
+                        <a:srgbClr val="DDDDDD"/>
+                      </a:solidFill>
+                      <a:prstDash val="solid"/>
+                      <a:round/>
+                      <a:headEnd type="none" w="med" len="med"/>
+                      <a:tailEnd type="none" w="med" len="med"/>
+                    </a:lnB>
+                    <a:noFill/>
+                  </a:tcPr>
+                </a:tc>
+                <a:extLst>
+                  <a:ext uri="{0D108BD9-81ED-4DB2-BD59-A6C34878D82A}">
+                    <a16:rowId xmlns:a16="http://schemas.microsoft.com/office/drawing/2014/main" val="365479551"/>
+                  </a:ext>
+                </a:extLst>
+              </a:tr>
+              <a:tr h="513826">
+                <a:tc>
+                  <a:txBody>
+                    <a:bodyPr/>
+                    <a:lstStyle/>
+                    <a:p>
+                      <a:pPr algn="l">
+                        <a:buNone/>
+                      </a:pPr>
+                      <a:r>
+                        <a:rPr lang="en-GB" sz="900">
+                          <a:effectLst/>
+                        </a:rPr>
+                        <a:t>Fragmentierung</a:t>
+                      </a:r>
+                    </a:p>
+                  </a:txBody>
+                  <a:tcPr marL="40143" marR="40143" marT="40143" marB="40143" anchor="ctr">
+                    <a:lnL w="9525" cap="flat" cmpd="sng" algn="ctr">
+                      <a:solidFill>
+                        <a:srgbClr val="DDDDDD"/>
+                      </a:solidFill>
+                      <a:prstDash val="solid"/>
+                      <a:round/>
+                      <a:headEnd type="none" w="med" len="med"/>
+                      <a:tailEnd type="none" w="med" len="med"/>
+                    </a:lnL>
+                    <a:lnR w="9525" cap="flat" cmpd="sng" algn="ctr">
+                      <a:solidFill>
+                        <a:srgbClr val="DDDDDD"/>
+                      </a:solidFill>
+                      <a:prstDash val="solid"/>
+                      <a:round/>
+                      <a:headEnd type="none" w="med" len="med"/>
+                      <a:tailEnd type="none" w="med" len="med"/>
+                    </a:lnR>
+                    <a:lnT w="9525" cap="flat" cmpd="sng" algn="ctr">
+                      <a:solidFill>
+                        <a:srgbClr val="DDDDDD"/>
+                      </a:solidFill>
+                      <a:prstDash val="solid"/>
+                      <a:round/>
+                      <a:headEnd type="none" w="med" len="med"/>
+                      <a:tailEnd type="none" w="med" len="med"/>
+                    </a:lnT>
+                    <a:lnB w="9525" cap="flat" cmpd="sng" algn="ctr">
+                      <a:solidFill>
+                        <a:srgbClr val="DDDDDD"/>
+                      </a:solidFill>
+                      <a:prstDash val="solid"/>
+                      <a:round/>
+                      <a:headEnd type="none" w="med" len="med"/>
+                      <a:tailEnd type="none" w="med" len="med"/>
+                    </a:lnB>
+                    <a:noFill/>
+                  </a:tcPr>
+                </a:tc>
+                <a:tc>
+                  <a:txBody>
+                    <a:bodyPr/>
+                    <a:lstStyle/>
+                    <a:p>
+                      <a:pPr algn="l">
+                        <a:buNone/>
+                      </a:pPr>
+                      <a:r>
+                        <a:rPr lang="de-DE" sz="900" dirty="0">
+                          <a:effectLst/>
+                        </a:rPr>
+                        <a:t>Page‑Fragmentierung, Index‑Wartung nötig.</a:t>
+                      </a:r>
+                    </a:p>
+                    <a:p>
+                      <a:pPr algn="l">
+                        <a:buNone/>
+                      </a:pPr>
+                      <a:endParaRPr lang="de-DE" sz="900" dirty="0">
+                        <a:effectLst/>
+                      </a:endParaRPr>
+                    </a:p>
+                  </a:txBody>
+                  <a:tcPr marL="40143" marR="40143" marT="40143" marB="40143" anchor="ctr">
+                    <a:lnL w="9525" cap="flat" cmpd="sng" algn="ctr">
+                      <a:solidFill>
+                        <a:srgbClr val="DDDDDD"/>
+                      </a:solidFill>
+                      <a:prstDash val="solid"/>
+                      <a:round/>
+                      <a:headEnd type="none" w="med" len="med"/>
+                      <a:tailEnd type="none" w="med" len="med"/>
+                    </a:lnL>
+                    <a:lnR w="9525" cap="flat" cmpd="sng" algn="ctr">
+                      <a:solidFill>
+                        <a:srgbClr val="DDDDDD"/>
+                      </a:solidFill>
+                      <a:prstDash val="solid"/>
+                      <a:round/>
+                      <a:headEnd type="none" w="med" len="med"/>
+                      <a:tailEnd type="none" w="med" len="med"/>
+                    </a:lnR>
+                    <a:lnT w="9525" cap="flat" cmpd="sng" algn="ctr">
+                      <a:solidFill>
+                        <a:srgbClr val="DDDDDD"/>
+                      </a:solidFill>
+                      <a:prstDash val="solid"/>
+                      <a:round/>
+                      <a:headEnd type="none" w="med" len="med"/>
+                      <a:tailEnd type="none" w="med" len="med"/>
+                    </a:lnT>
+                    <a:lnB w="9525" cap="flat" cmpd="sng" algn="ctr">
+                      <a:solidFill>
+                        <a:srgbClr val="DDDDDD"/>
+                      </a:solidFill>
+                      <a:prstDash val="solid"/>
+                      <a:round/>
+                      <a:headEnd type="none" w="med" len="med"/>
+                      <a:tailEnd type="none" w="med" len="med"/>
+                    </a:lnB>
+                    <a:noFill/>
+                  </a:tcPr>
+                </a:tc>
+                <a:tc>
+                  <a:txBody>
+                    <a:bodyPr/>
+                    <a:lstStyle/>
+                    <a:p>
+                      <a:pPr algn="l">
+                        <a:buNone/>
+                      </a:pPr>
+                      <a:r>
+                        <a:rPr lang="de-DE" sz="900" dirty="0">
+                          <a:effectLst/>
+                        </a:rPr>
+                        <a:t>Keine Page‑Fragmentierung, Hintergrund‑</a:t>
+                      </a:r>
+                      <a:r>
+                        <a:rPr lang="de-DE" sz="900" dirty="0" err="1">
+                          <a:effectLst/>
+                        </a:rPr>
+                        <a:t>MERGE</a:t>
+                      </a:r>
+                      <a:r>
+                        <a:rPr lang="de-DE" sz="900" dirty="0">
+                          <a:effectLst/>
+                        </a:rPr>
+                        <a:t> kompaktiert Files.</a:t>
+                      </a:r>
+                    </a:p>
+                  </a:txBody>
+                  <a:tcPr marL="40143" marR="40143" marT="40143" marB="40143" anchor="ctr">
+                    <a:lnL w="9525" cap="flat" cmpd="sng" algn="ctr">
+                      <a:solidFill>
+                        <a:srgbClr val="DDDDDD"/>
+                      </a:solidFill>
+                      <a:prstDash val="solid"/>
+                      <a:round/>
+                      <a:headEnd type="none" w="med" len="med"/>
+                      <a:tailEnd type="none" w="med" len="med"/>
+                    </a:lnL>
+                    <a:lnR w="9525" cap="flat" cmpd="sng" algn="ctr">
+                      <a:solidFill>
+                        <a:srgbClr val="DDDDDD"/>
+                      </a:solidFill>
+                      <a:prstDash val="solid"/>
+                      <a:round/>
+                      <a:headEnd type="none" w="med" len="med"/>
+                      <a:tailEnd type="none" w="med" len="med"/>
+                    </a:lnR>
+                    <a:lnT w="9525" cap="flat" cmpd="sng" algn="ctr">
+                      <a:solidFill>
+                        <a:srgbClr val="DDDDDD"/>
+                      </a:solidFill>
+                      <a:prstDash val="solid"/>
+                      <a:round/>
+                      <a:headEnd type="none" w="med" len="med"/>
+                      <a:tailEnd type="none" w="med" len="med"/>
+                    </a:lnT>
+                    <a:lnB w="9525" cap="flat" cmpd="sng" algn="ctr">
+                      <a:solidFill>
+                        <a:srgbClr val="DDDDDD"/>
+                      </a:solidFill>
+                      <a:prstDash val="solid"/>
+                      <a:round/>
+                      <a:headEnd type="none" w="med" len="med"/>
+                      <a:tailEnd type="none" w="med" len="med"/>
+                    </a:lnB>
+                    <a:noFill/>
+                  </a:tcPr>
+                </a:tc>
+                <a:extLst>
+                  <a:ext uri="{0D108BD9-81ED-4DB2-BD59-A6C34878D82A}">
+                    <a16:rowId xmlns:a16="http://schemas.microsoft.com/office/drawing/2014/main" val="1841073391"/>
+                  </a:ext>
+                </a:extLst>
+              </a:tr>
+              <a:tr h="513826">
+                <a:tc>
+                  <a:txBody>
+                    <a:bodyPr/>
+                    <a:lstStyle/>
+                    <a:p>
+                      <a:pPr algn="l">
+                        <a:buNone/>
+                      </a:pPr>
+                      <a:r>
+                        <a:rPr lang="en-GB" sz="900" dirty="0" err="1">
+                          <a:effectLst/>
+                        </a:rPr>
+                        <a:t>DDL</a:t>
+                      </a:r>
+                      <a:r>
+                        <a:rPr lang="en-GB" sz="900" dirty="0">
+                          <a:effectLst/>
+                        </a:rPr>
+                        <a:t> (Data Definition Language)</a:t>
+                      </a:r>
+                    </a:p>
+                  </a:txBody>
+                  <a:tcPr marL="40143" marR="40143" marT="40143" marB="40143" anchor="ctr">
+                    <a:lnL w="9525" cap="flat" cmpd="sng" algn="ctr">
+                      <a:solidFill>
+                        <a:srgbClr val="DDDDDD"/>
+                      </a:solidFill>
+                      <a:prstDash val="solid"/>
+                      <a:round/>
+                      <a:headEnd type="none" w="med" len="med"/>
+                      <a:tailEnd type="none" w="med" len="med"/>
+                    </a:lnL>
+                    <a:lnR w="9525" cap="flat" cmpd="sng" algn="ctr">
+                      <a:solidFill>
+                        <a:srgbClr val="DDDDDD"/>
+                      </a:solidFill>
+                      <a:prstDash val="solid"/>
+                      <a:round/>
+                      <a:headEnd type="none" w="med" len="med"/>
+                      <a:tailEnd type="none" w="med" len="med"/>
+                    </a:lnR>
+                    <a:lnT w="9525" cap="flat" cmpd="sng" algn="ctr">
+                      <a:solidFill>
+                        <a:srgbClr val="DDDDDD"/>
+                      </a:solidFill>
+                      <a:prstDash val="solid"/>
+                      <a:round/>
+                      <a:headEnd type="none" w="med" len="med"/>
+                      <a:tailEnd type="none" w="med" len="med"/>
+                    </a:lnT>
+                    <a:lnB w="9525" cap="flat" cmpd="sng" algn="ctr">
+                      <a:solidFill>
+                        <a:srgbClr val="DDDDDD"/>
+                      </a:solidFill>
+                      <a:prstDash val="solid"/>
+                      <a:round/>
+                      <a:headEnd type="none" w="med" len="med"/>
+                      <a:tailEnd type="none" w="med" len="med"/>
+                    </a:lnB>
+                    <a:noFill/>
+                  </a:tcPr>
+                </a:tc>
+                <a:tc>
+                  <a:txBody>
+                    <a:bodyPr/>
+                    <a:lstStyle/>
+                    <a:p>
+                      <a:pPr algn="l">
+                        <a:buNone/>
+                      </a:pPr>
+                      <a:r>
+                        <a:rPr lang="en-US" sz="900" dirty="0">
+                          <a:effectLst/>
+                        </a:rPr>
+                        <a:t>Standard CREATE TABLE.</a:t>
+                      </a:r>
+                    </a:p>
+                  </a:txBody>
+                  <a:tcPr marL="40143" marR="40143" marT="40143" marB="40143" anchor="ctr">
+                    <a:lnL w="9525" cap="flat" cmpd="sng" algn="ctr">
+                      <a:solidFill>
+                        <a:srgbClr val="DDDDDD"/>
+                      </a:solidFill>
+                      <a:prstDash val="solid"/>
+                      <a:round/>
+                      <a:headEnd type="none" w="med" len="med"/>
+                      <a:tailEnd type="none" w="med" len="med"/>
+                    </a:lnL>
+                    <a:lnR w="9525" cap="flat" cmpd="sng" algn="ctr">
+                      <a:solidFill>
+                        <a:srgbClr val="DDDDDD"/>
+                      </a:solidFill>
+                      <a:prstDash val="solid"/>
+                      <a:round/>
+                      <a:headEnd type="none" w="med" len="med"/>
+                      <a:tailEnd type="none" w="med" len="med"/>
+                    </a:lnR>
+                    <a:lnT w="9525" cap="flat" cmpd="sng" algn="ctr">
+                      <a:solidFill>
+                        <a:srgbClr val="DDDDDD"/>
+                      </a:solidFill>
+                      <a:prstDash val="solid"/>
+                      <a:round/>
+                      <a:headEnd type="none" w="med" len="med"/>
+                      <a:tailEnd type="none" w="med" len="med"/>
+                    </a:lnT>
+                    <a:lnB w="9525" cap="flat" cmpd="sng" algn="ctr">
+                      <a:solidFill>
+                        <a:srgbClr val="DDDDDD"/>
+                      </a:solidFill>
+                      <a:prstDash val="solid"/>
+                      <a:round/>
+                      <a:headEnd type="none" w="med" len="med"/>
+                      <a:tailEnd type="none" w="med" len="med"/>
+                    </a:lnB>
+                    <a:noFill/>
+                  </a:tcPr>
+                </a:tc>
+                <a:tc>
+                  <a:txBody>
+                    <a:bodyPr/>
+                    <a:lstStyle/>
+                    <a:p>
+                      <a:pPr algn="l">
+                        <a:buNone/>
+                      </a:pPr>
+                      <a:r>
+                        <a:rPr lang="en-US" sz="900" dirty="0" err="1">
+                          <a:effectLst/>
+                        </a:rPr>
+                        <a:t>MEMORY_OPTIMIZED</a:t>
+                      </a:r>
+                      <a:r>
+                        <a:rPr lang="en-US" sz="900" dirty="0">
+                          <a:effectLst/>
+                        </a:rPr>
+                        <a:t> = ON, DURABILITY‑Option, </a:t>
+                      </a:r>
+                      <a:r>
+                        <a:rPr lang="en-US" sz="900" dirty="0" err="1">
+                          <a:effectLst/>
+                        </a:rPr>
+                        <a:t>spezielle</a:t>
+                      </a:r>
+                      <a:r>
+                        <a:rPr lang="en-US" sz="900" dirty="0">
+                          <a:effectLst/>
+                        </a:rPr>
+                        <a:t> Filegroup </a:t>
+                      </a:r>
+                      <a:r>
+                        <a:rPr lang="en-US" sz="900" dirty="0" err="1">
+                          <a:effectLst/>
+                        </a:rPr>
+                        <a:t>nötig</a:t>
+                      </a:r>
+                      <a:r>
+                        <a:rPr lang="en-US" sz="900" dirty="0">
+                          <a:effectLst/>
+                        </a:rPr>
+                        <a:t>.</a:t>
+                      </a:r>
+                    </a:p>
+                  </a:txBody>
+                  <a:tcPr marL="40143" marR="40143" marT="40143" marB="40143" anchor="ctr">
+                    <a:lnL w="9525" cap="flat" cmpd="sng" algn="ctr">
+                      <a:solidFill>
+                        <a:srgbClr val="DDDDDD"/>
+                      </a:solidFill>
+                      <a:prstDash val="solid"/>
+                      <a:round/>
+                      <a:headEnd type="none" w="med" len="med"/>
+                      <a:tailEnd type="none" w="med" len="med"/>
+                    </a:lnL>
+                    <a:lnR w="9525" cap="flat" cmpd="sng" algn="ctr">
+                      <a:solidFill>
+                        <a:srgbClr val="DDDDDD"/>
+                      </a:solidFill>
+                      <a:prstDash val="solid"/>
+                      <a:round/>
+                      <a:headEnd type="none" w="med" len="med"/>
+                      <a:tailEnd type="none" w="med" len="med"/>
+                    </a:lnR>
+                    <a:lnT w="9525" cap="flat" cmpd="sng" algn="ctr">
+                      <a:solidFill>
+                        <a:srgbClr val="DDDDDD"/>
+                      </a:solidFill>
+                      <a:prstDash val="solid"/>
+                      <a:round/>
+                      <a:headEnd type="none" w="med" len="med"/>
+                      <a:tailEnd type="none" w="med" len="med"/>
+                    </a:lnT>
+                    <a:lnB w="9525" cap="flat" cmpd="sng" algn="ctr">
+                      <a:solidFill>
+                        <a:srgbClr val="DDDDDD"/>
+                      </a:solidFill>
+                      <a:prstDash val="solid"/>
+                      <a:round/>
+                      <a:headEnd type="none" w="med" len="med"/>
+                      <a:tailEnd type="none" w="med" len="med"/>
+                    </a:lnB>
+                    <a:noFill/>
+                  </a:tcPr>
+                </a:tc>
+                <a:extLst>
+                  <a:ext uri="{0D108BD9-81ED-4DB2-BD59-A6C34878D82A}">
+                    <a16:rowId xmlns:a16="http://schemas.microsoft.com/office/drawing/2014/main" val="2178630465"/>
+                  </a:ext>
+                </a:extLst>
+              </a:tr>
+              <a:tr h="513826">
+                <a:tc>
+                  <a:txBody>
+                    <a:bodyPr/>
+                    <a:lstStyle/>
+                    <a:p>
+                      <a:pPr algn="l">
+                        <a:buNone/>
+                      </a:pPr>
+                      <a:r>
+                        <a:rPr lang="en-GB" sz="900" dirty="0" err="1">
+                          <a:effectLst/>
+                        </a:rPr>
+                        <a:t>Vorteil</a:t>
+                      </a:r>
+                      <a:r>
+                        <a:rPr lang="en-GB" sz="900" dirty="0">
+                          <a:effectLst/>
+                        </a:rPr>
+                        <a:t> </a:t>
+                      </a:r>
+                      <a:r>
+                        <a:rPr lang="en-GB" sz="900" dirty="0" err="1">
+                          <a:effectLst/>
+                        </a:rPr>
+                        <a:t>bei</a:t>
+                      </a:r>
+                      <a:endParaRPr lang="en-GB" sz="900" dirty="0">
+                        <a:effectLst/>
+                      </a:endParaRPr>
+                    </a:p>
+                  </a:txBody>
+                  <a:tcPr marL="40143" marR="40143" marT="40143" marB="40143" anchor="ctr">
+                    <a:lnL w="9525" cap="flat" cmpd="sng" algn="ctr">
+                      <a:solidFill>
+                        <a:srgbClr val="DDDDDD"/>
+                      </a:solidFill>
+                      <a:prstDash val="solid"/>
+                      <a:round/>
+                      <a:headEnd type="none" w="med" len="med"/>
+                      <a:tailEnd type="none" w="med" len="med"/>
+                    </a:lnL>
+                    <a:lnR w="9525" cap="flat" cmpd="sng" algn="ctr">
+                      <a:solidFill>
+                        <a:srgbClr val="DDDDDD"/>
+                      </a:solidFill>
+                      <a:prstDash val="solid"/>
+                      <a:round/>
+                      <a:headEnd type="none" w="med" len="med"/>
+                      <a:tailEnd type="none" w="med" len="med"/>
+                    </a:lnR>
+                    <a:lnT w="9525" cap="flat" cmpd="sng" algn="ctr">
+                      <a:solidFill>
+                        <a:srgbClr val="DDDDDD"/>
+                      </a:solidFill>
+                      <a:prstDash val="solid"/>
+                      <a:round/>
+                      <a:headEnd type="none" w="med" len="med"/>
+                      <a:tailEnd type="none" w="med" len="med"/>
+                    </a:lnT>
+                    <a:lnB w="9525" cap="flat" cmpd="sng" algn="ctr">
+                      <a:solidFill>
+                        <a:srgbClr val="DDDDDD"/>
+                      </a:solidFill>
+                      <a:prstDash val="solid"/>
+                      <a:round/>
+                      <a:headEnd type="none" w="med" len="med"/>
+                      <a:tailEnd type="none" w="med" len="med"/>
+                    </a:lnB>
+                    <a:noFill/>
+                  </a:tcPr>
+                </a:tc>
+                <a:tc>
+                  <a:txBody>
+                    <a:bodyPr/>
+                    <a:lstStyle/>
+                    <a:p>
+                      <a:pPr algn="l">
+                        <a:buNone/>
+                      </a:pPr>
+                      <a:r>
+                        <a:rPr lang="en-GB" sz="900" dirty="0">
+                          <a:effectLst/>
+                        </a:rPr>
+                        <a:t>Allgemeine </a:t>
+                      </a:r>
+                      <a:r>
+                        <a:rPr lang="en-GB" sz="900" dirty="0" err="1">
+                          <a:effectLst/>
+                        </a:rPr>
+                        <a:t>OLTP</a:t>
+                      </a:r>
+                      <a:r>
+                        <a:rPr lang="en-GB" sz="900" dirty="0">
+                          <a:effectLst/>
+                        </a:rPr>
+                        <a:t>/Reporting‑</a:t>
+                      </a:r>
+                      <a:r>
+                        <a:rPr lang="en-GB" sz="900" dirty="0" err="1">
+                          <a:effectLst/>
+                        </a:rPr>
+                        <a:t>Tabellen</a:t>
+                      </a:r>
+                      <a:r>
+                        <a:rPr lang="en-GB" sz="900" dirty="0">
+                          <a:effectLst/>
+                        </a:rPr>
+                        <a:t>.</a:t>
+                      </a:r>
+                    </a:p>
+                  </a:txBody>
+                  <a:tcPr marL="40143" marR="40143" marT="40143" marB="40143" anchor="ctr">
+                    <a:lnL w="9525" cap="flat" cmpd="sng" algn="ctr">
+                      <a:solidFill>
+                        <a:srgbClr val="DDDDDD"/>
+                      </a:solidFill>
+                      <a:prstDash val="solid"/>
+                      <a:round/>
+                      <a:headEnd type="none" w="med" len="med"/>
+                      <a:tailEnd type="none" w="med" len="med"/>
+                    </a:lnL>
+                    <a:lnR w="9525" cap="flat" cmpd="sng" algn="ctr">
+                      <a:solidFill>
+                        <a:srgbClr val="DDDDDD"/>
+                      </a:solidFill>
+                      <a:prstDash val="solid"/>
+                      <a:round/>
+                      <a:headEnd type="none" w="med" len="med"/>
+                      <a:tailEnd type="none" w="med" len="med"/>
+                    </a:lnR>
+                    <a:lnT w="9525" cap="flat" cmpd="sng" algn="ctr">
+                      <a:solidFill>
+                        <a:srgbClr val="DDDDDD"/>
+                      </a:solidFill>
+                      <a:prstDash val="solid"/>
+                      <a:round/>
+                      <a:headEnd type="none" w="med" len="med"/>
+                      <a:tailEnd type="none" w="med" len="med"/>
+                    </a:lnT>
+                    <a:lnB w="9525" cap="flat" cmpd="sng" algn="ctr">
+                      <a:solidFill>
+                        <a:srgbClr val="DDDDDD"/>
+                      </a:solidFill>
+                      <a:prstDash val="solid"/>
+                      <a:round/>
+                      <a:headEnd type="none" w="med" len="med"/>
+                      <a:tailEnd type="none" w="med" len="med"/>
+                    </a:lnB>
+                    <a:noFill/>
+                  </a:tcPr>
+                </a:tc>
+                <a:tc>
+                  <a:txBody>
+                    <a:bodyPr/>
+                    <a:lstStyle/>
+                    <a:p>
+                      <a:pPr algn="l">
+                        <a:buNone/>
+                      </a:pPr>
+                      <a:r>
+                        <a:rPr lang="en-US" sz="900" dirty="0">
+                          <a:effectLst/>
+                        </a:rPr>
+                        <a:t>High‑Throughput‑</a:t>
+                      </a:r>
+                      <a:r>
+                        <a:rPr lang="en-US" sz="900" dirty="0" err="1">
+                          <a:effectLst/>
+                        </a:rPr>
+                        <a:t>OLTP</a:t>
+                      </a:r>
+                      <a:r>
+                        <a:rPr lang="en-US" sz="900" dirty="0">
+                          <a:effectLst/>
+                        </a:rPr>
+                        <a:t>, Session‑State, Queues, Hot‑Lookups.</a:t>
+                      </a:r>
+                    </a:p>
+                  </a:txBody>
+                  <a:tcPr marL="40143" marR="40143" marT="40143" marB="40143" anchor="ctr">
+                    <a:lnL w="9525" cap="flat" cmpd="sng" algn="ctr">
+                      <a:solidFill>
+                        <a:srgbClr val="DDDDDD"/>
+                      </a:solidFill>
+                      <a:prstDash val="solid"/>
+                      <a:round/>
+                      <a:headEnd type="none" w="med" len="med"/>
+                      <a:tailEnd type="none" w="med" len="med"/>
+                    </a:lnL>
+                    <a:lnR w="9525" cap="flat" cmpd="sng" algn="ctr">
+                      <a:solidFill>
+                        <a:srgbClr val="DDDDDD"/>
+                      </a:solidFill>
+                      <a:prstDash val="solid"/>
+                      <a:round/>
+                      <a:headEnd type="none" w="med" len="med"/>
+                      <a:tailEnd type="none" w="med" len="med"/>
+                    </a:lnR>
+                    <a:lnT w="9525" cap="flat" cmpd="sng" algn="ctr">
+                      <a:solidFill>
+                        <a:srgbClr val="DDDDDD"/>
+                      </a:solidFill>
+                      <a:prstDash val="solid"/>
+                      <a:round/>
+                      <a:headEnd type="none" w="med" len="med"/>
+                      <a:tailEnd type="none" w="med" len="med"/>
+                    </a:lnT>
+                    <a:lnB w="9525" cap="flat" cmpd="sng" algn="ctr">
+                      <a:solidFill>
+                        <a:srgbClr val="DDDDDD"/>
+                      </a:solidFill>
+                      <a:prstDash val="solid"/>
+                      <a:round/>
+                      <a:headEnd type="none" w="med" len="med"/>
+                      <a:tailEnd type="none" w="med" len="med"/>
+                    </a:lnB>
+                    <a:noFill/>
+                  </a:tcPr>
+                </a:tc>
+                <a:extLst>
+                  <a:ext uri="{0D108BD9-81ED-4DB2-BD59-A6C34878D82A}">
+                    <a16:rowId xmlns:a16="http://schemas.microsoft.com/office/drawing/2014/main" val="4232391107"/>
+                  </a:ext>
+                </a:extLst>
+              </a:tr>
+            </a:tbl>
+          </a:graphicData>
+        </a:graphic>
+      </p:graphicFrame>
+    </p:spTree>
+    <p:extLst>
+      <p:ext uri="{BB962C8B-B14F-4D97-AF65-F5344CB8AC3E}">
+        <p14:creationId xmlns:p14="http://schemas.microsoft.com/office/powerpoint/2010/main" val="3884400882"/>
       </p:ext>
     </p:extLst>
   </p:cSld>

</xml_diff>